<commit_message>
Slides: drop 3-page-paper aside; rewrite slide 14 as Verdict (V5 + money answer)
Slide 6: 'Why simple is right for a 3-page paper' -> 'Why we kept it simple'
  (deck shouldn't mention the report)

Slide 14: Takeaways list -> Verdict slide answering the two real questions:
  · LEFT: Most effective method = V5 event overreaction
    H1 +0.0075 p<0.0001 · H4 +0.0138 p<0.0001 · 'The bias is statistically real'
  · RIGHT: Can it make money?
    TODAY · NO (n=1 -40%, Kalshi +95% artifact)
    BIAS · YES (V5 pre-reg passed)
    PATH · CLEAR (power backtest -> V5-targeted Kalshi deploy)
    'Gated on data scale, not methodology'

Speaker script updated to match new slide 14 (~45s).
</commit_message>
<xml_diff>
--- a/slides/final_deck.pptx
+++ b/slides/final_deck.pptx
@@ -4184,7 +4184,7 @@
                 <a:ea typeface="Georgia" pitchFamily="34" charset="-122"/>
                 <a:cs typeface="Georgia" pitchFamily="34" charset="-120"/>
               </a:rPr>
-              <a:t>Takeaways</a:t>
+              <a:t>Verdict · what works + can it make money?</a:t>
             </a:r>
             <a:endParaRPr lang="en-US" sz="2800" dirty="0"/>
           </a:p>
@@ -4223,7 +4223,7 @@
                 <a:ea typeface="Calibri" pitchFamily="34" charset="-122"/>
                 <a:cs typeface="Calibri" pitchFamily="34" charset="-120"/>
               </a:rPr>
-              <a:t>What we shipped, and what it says</a:t>
+              <a:t>The two questions, answered honestly</a:t>
             </a:r>
             <a:endParaRPr lang="en-US" sz="1400" dirty="0"/>
           </a:p>
@@ -4260,10 +4260,969 @@
         </p:nvSpPr>
         <p:spPr>
           <a:xfrm>
-            <a:off x="502920" y="1554480"/>
-            <a:ext cx="457200" cy="457200"/>
-          </a:xfrm>
-          <a:prstGeom prst="ellipse">
+            <a:off x="502920" y="1417320"/>
+            <a:ext cx="5486400" cy="4846320"/>
+          </a:xfrm>
+          <a:prstGeom prst="roundRect">
+            <a:avLst>
+              <a:gd name="adj" fmla="val 1887"/>
+            </a:avLst>
+          </a:prstGeom>
+          <a:solidFill>
+            <a:srgbClr val="F6F6F2"/>
+          </a:solidFill>
+          <a:ln w="19050">
+            <a:solidFill>
+              <a:srgbClr val="1C7293"/>
+            </a:solidFill>
+            <a:prstDash val="solid"/>
+          </a:ln>
+        </p:spPr>
+      </p:sp>
+      <p:sp>
+        <p:nvSpPr>
+          <p:cNvPr id="6" name="Text 4"/>
+          <p:cNvSpPr/>
+          <p:nvPr/>
+        </p:nvSpPr>
+        <p:spPr>
+          <a:xfrm>
+            <a:off x="685800" y="1554480"/>
+            <a:ext cx="5120640" cy="365760"/>
+          </a:xfrm>
+          <a:prstGeom prst="rect">
+            <a:avLst/>
+          </a:prstGeom>
+          <a:noFill/>
+          <a:ln/>
+        </p:spPr>
+        <p:txBody>
+          <a:bodyPr wrap="square" rtlCol="0" anchor="ctr"/>
+          <a:lstStyle/>
+          <a:p>
+            <a:pPr indent="0" marL="0">
+              <a:buNone/>
+            </a:pPr>
+            <a:r>
+              <a:rPr lang="en-US" sz="1200" b="1" dirty="0">
+                <a:solidFill>
+                  <a:srgbClr val="13315C"/>
+                </a:solidFill>
+                <a:latin typeface="Calibri" pitchFamily="34" charset="0"/>
+                <a:ea typeface="Calibri" pitchFamily="34" charset="-122"/>
+                <a:cs typeface="Calibri" pitchFamily="34" charset="-120"/>
+              </a:rPr>
+              <a:t>MOST EFFECTIVE METHOD</a:t>
+            </a:r>
+            <a:endParaRPr lang="en-US" sz="1200" dirty="0"/>
+          </a:p>
+        </p:txBody>
+      </p:sp>
+      <p:sp>
+        <p:nvSpPr>
+          <p:cNvPr id="7" name="Text 5"/>
+          <p:cNvSpPr/>
+          <p:nvPr/>
+        </p:nvSpPr>
+        <p:spPr>
+          <a:xfrm>
+            <a:off x="685800" y="1920240"/>
+            <a:ext cx="5120640" cy="502920"/>
+          </a:xfrm>
+          <a:prstGeom prst="rect">
+            <a:avLst/>
+          </a:prstGeom>
+          <a:noFill/>
+          <a:ln/>
+        </p:spPr>
+        <p:txBody>
+          <a:bodyPr wrap="square" rtlCol="0" anchor="ctr"/>
+          <a:lstStyle/>
+          <a:p>
+            <a:pPr indent="0" marL="0">
+              <a:buNone/>
+            </a:pPr>
+            <a:r>
+              <a:rPr lang="en-US" sz="2000" b="1" dirty="0">
+                <a:solidFill>
+                  <a:srgbClr val="0B2545"/>
+                </a:solidFill>
+                <a:latin typeface="Georgia" pitchFamily="34" charset="0"/>
+                <a:ea typeface="Georgia" pitchFamily="34" charset="-122"/>
+                <a:cs typeface="Georgia" pitchFamily="34" charset="-120"/>
+              </a:rPr>
+              <a:t>V5 · Event-conditioned overreaction</a:t>
+            </a:r>
+            <a:endParaRPr lang="en-US" sz="2000" dirty="0"/>
+          </a:p>
+        </p:txBody>
+      </p:sp>
+      <p:sp>
+        <p:nvSpPr>
+          <p:cNvPr id="8" name="Text 6"/>
+          <p:cNvSpPr/>
+          <p:nvPr/>
+        </p:nvSpPr>
+        <p:spPr>
+          <a:xfrm>
+            <a:off x="685800" y="2423160"/>
+            <a:ext cx="5120640" cy="640080"/>
+          </a:xfrm>
+          <a:prstGeom prst="rect">
+            <a:avLst/>
+          </a:prstGeom>
+          <a:noFill/>
+          <a:ln/>
+        </p:spPr>
+        <p:txBody>
+          <a:bodyPr wrap="square" rtlCol="0" anchor="ctr"/>
+          <a:lstStyle/>
+          <a:p>
+            <a:pPr indent="0" marL="0">
+              <a:buNone/>
+            </a:pPr>
+            <a:r>
+              <a:rPr lang="en-US" sz="1300" i="1" dirty="0">
+                <a:solidFill>
+                  <a:srgbClr val="13315C"/>
+                </a:solidFill>
+                <a:latin typeface="Calibri" pitchFamily="34" charset="0"/>
+                <a:ea typeface="Calibri" pitchFamily="34" charset="-122"/>
+                <a:cs typeface="Calibri" pitchFamily="34" charset="-120"/>
+              </a:rPr>
+              <a:t>the only variant with a statistically significant finding on the held-out test season</a:t>
+            </a:r>
+            <a:endParaRPr lang="en-US" sz="1300" dirty="0"/>
+          </a:p>
+        </p:txBody>
+      </p:sp>
+      <p:graphicFrame>
+        <p:nvGraphicFramePr>
+          <p:cNvPr id="15" name="Table 0"/>
+          <p:cNvGraphicFramePr>
+            <a:graphicFrameLocks noGrp="1"/>
+          </p:cNvGraphicFramePr>
+          <p:nvPr>
+            <p:extLst>
+              <p:ext uri="{D42A27DB-BD31-4B8C-83A1-F6EECF244321}">
+                <p14:modId xmlns:p14="http://schemas.microsoft.com/office/powerpoint/2010/main" val="1579011935"/>
+              </p:ext>
+            </p:extLst>
+          </p:nvPr>
+        </p:nvGraphicFramePr>
+        <p:xfrm>
+          <a:off x="685800" y="3154680"/>
+          <a:ext cx="5120640" cy="914400"/>
+        </p:xfrm>
+        <a:graphic>
+          <a:graphicData uri="http://schemas.openxmlformats.org/drawingml/2006/table">
+            <a:tbl>
+              <a:tblPr/>
+              <a:tblGrid>
+                <a:gridCol w="2468880"/>
+                <a:gridCol w="1325880"/>
+                <a:gridCol w="1325880"/>
+              </a:tblGrid>
+              <a:tr h="457200">
+                <a:tc>
+                  <a:txBody>
+                    <a:bodyPr/>
+                    <a:lstStyle/>
+                    <a:p>
+                      <a:pPr indent="0" marL="0">
+                        <a:buNone/>
+                      </a:pPr>
+                      <a:r>
+                        <a:rPr lang="en-US" sz="1100" b="1" dirty="0">
+                          <a:solidFill>
+                            <a:srgbClr val="F6F6F2"/>
+                          </a:solidFill>
+                        </a:rPr>
+                        <a:t>Test</a:t>
+                      </a:r>
+                      <a:endParaRPr lang="en-US" sz="1100" dirty="0"/>
+                    </a:p>
+                  </a:txBody>
+                  <a:tcPr marL="91440" marR="91440" marT="45720" marB="45720">
+                    <a:lnL w="12700" cap="flat" cmpd="sng" algn="ctr">
+                      <a:solidFill>
+                        <a:srgbClr val="8DA9C4"/>
+                      </a:solidFill>
+                      <a:prstDash val="solid"/>
+                      <a:round/>
+                      <a:headEnd type="none" w="med" len="med"/>
+                      <a:tailEnd type="none" w="med" len="med"/>
+                    </a:lnL>
+                    <a:lnR w="12700" cap="flat" cmpd="sng" algn="ctr">
+                      <a:solidFill>
+                        <a:srgbClr val="8DA9C4"/>
+                      </a:solidFill>
+                      <a:prstDash val="solid"/>
+                      <a:round/>
+                      <a:headEnd type="none" w="med" len="med"/>
+                      <a:tailEnd type="none" w="med" len="med"/>
+                    </a:lnR>
+                    <a:lnT w="12700" cap="flat" cmpd="sng" algn="ctr">
+                      <a:solidFill>
+                        <a:srgbClr val="8DA9C4"/>
+                      </a:solidFill>
+                      <a:prstDash val="solid"/>
+                      <a:round/>
+                      <a:headEnd type="none" w="med" len="med"/>
+                      <a:tailEnd type="none" w="med" len="med"/>
+                    </a:lnT>
+                    <a:lnB w="12700" cap="flat" cmpd="sng" algn="ctr">
+                      <a:solidFill>
+                        <a:srgbClr val="8DA9C4"/>
+                      </a:solidFill>
+                      <a:prstDash val="solid"/>
+                      <a:round/>
+                      <a:headEnd type="none" w="med" len="med"/>
+                      <a:tailEnd type="none" w="med" len="med"/>
+                    </a:lnB>
+                    <a:solidFill>
+                      <a:srgbClr val="0B2545"/>
+                    </a:solidFill>
+                  </a:tcPr>
+                </a:tc>
+                <a:tc>
+                  <a:txBody>
+                    <a:bodyPr/>
+                    <a:lstStyle/>
+                    <a:p>
+                      <a:pPr algn="ctr" indent="0" marL="0">
+                        <a:buNone/>
+                      </a:pPr>
+                      <a:r>
+                        <a:rPr lang="en-US" sz="1100" b="1" dirty="0">
+                          <a:solidFill>
+                            <a:srgbClr val="F6F6F2"/>
+                          </a:solidFill>
+                        </a:rPr>
+                        <a:t>Shift</a:t>
+                      </a:r>
+                      <a:endParaRPr lang="en-US" sz="1100" dirty="0"/>
+                    </a:p>
+                  </a:txBody>
+                  <a:tcPr marL="91440" marR="91440" marT="45720" marB="45720">
+                    <a:lnL w="12700" cap="flat" cmpd="sng" algn="ctr">
+                      <a:solidFill>
+                        <a:srgbClr val="8DA9C4"/>
+                      </a:solidFill>
+                      <a:prstDash val="solid"/>
+                      <a:round/>
+                      <a:headEnd type="none" w="med" len="med"/>
+                      <a:tailEnd type="none" w="med" len="med"/>
+                    </a:lnL>
+                    <a:lnR w="12700" cap="flat" cmpd="sng" algn="ctr">
+                      <a:solidFill>
+                        <a:srgbClr val="8DA9C4"/>
+                      </a:solidFill>
+                      <a:prstDash val="solid"/>
+                      <a:round/>
+                      <a:headEnd type="none" w="med" len="med"/>
+                      <a:tailEnd type="none" w="med" len="med"/>
+                    </a:lnR>
+                    <a:lnT w="12700" cap="flat" cmpd="sng" algn="ctr">
+                      <a:solidFill>
+                        <a:srgbClr val="8DA9C4"/>
+                      </a:solidFill>
+                      <a:prstDash val="solid"/>
+                      <a:round/>
+                      <a:headEnd type="none" w="med" len="med"/>
+                      <a:tailEnd type="none" w="med" len="med"/>
+                    </a:lnT>
+                    <a:lnB w="12700" cap="flat" cmpd="sng" algn="ctr">
+                      <a:solidFill>
+                        <a:srgbClr val="8DA9C4"/>
+                      </a:solidFill>
+                      <a:prstDash val="solid"/>
+                      <a:round/>
+                      <a:headEnd type="none" w="med" len="med"/>
+                      <a:tailEnd type="none" w="med" len="med"/>
+                    </a:lnB>
+                    <a:solidFill>
+                      <a:srgbClr val="0B2545"/>
+                    </a:solidFill>
+                  </a:tcPr>
+                </a:tc>
+                <a:tc>
+                  <a:txBody>
+                    <a:bodyPr/>
+                    <a:lstStyle/>
+                    <a:p>
+                      <a:pPr algn="ctr" indent="0" marL="0">
+                        <a:buNone/>
+                      </a:pPr>
+                      <a:r>
+                        <a:rPr lang="en-US" sz="1100" b="1" dirty="0">
+                          <a:solidFill>
+                            <a:srgbClr val="F6F6F2"/>
+                          </a:solidFill>
+                        </a:rPr>
+                        <a:t>p-value</a:t>
+                      </a:r>
+                      <a:endParaRPr lang="en-US" sz="1100" dirty="0"/>
+                    </a:p>
+                  </a:txBody>
+                  <a:tcPr marL="91440" marR="91440" marT="45720" marB="45720">
+                    <a:lnL w="12700" cap="flat" cmpd="sng" algn="ctr">
+                      <a:solidFill>
+                        <a:srgbClr val="8DA9C4"/>
+                      </a:solidFill>
+                      <a:prstDash val="solid"/>
+                      <a:round/>
+                      <a:headEnd type="none" w="med" len="med"/>
+                      <a:tailEnd type="none" w="med" len="med"/>
+                    </a:lnL>
+                    <a:lnR w="12700" cap="flat" cmpd="sng" algn="ctr">
+                      <a:solidFill>
+                        <a:srgbClr val="8DA9C4"/>
+                      </a:solidFill>
+                      <a:prstDash val="solid"/>
+                      <a:round/>
+                      <a:headEnd type="none" w="med" len="med"/>
+                      <a:tailEnd type="none" w="med" len="med"/>
+                    </a:lnR>
+                    <a:lnT w="12700" cap="flat" cmpd="sng" algn="ctr">
+                      <a:solidFill>
+                        <a:srgbClr val="8DA9C4"/>
+                      </a:solidFill>
+                      <a:prstDash val="solid"/>
+                      <a:round/>
+                      <a:headEnd type="none" w="med" len="med"/>
+                      <a:tailEnd type="none" w="med" len="med"/>
+                    </a:lnT>
+                    <a:lnB w="12700" cap="flat" cmpd="sng" algn="ctr">
+                      <a:solidFill>
+                        <a:srgbClr val="8DA9C4"/>
+                      </a:solidFill>
+                      <a:prstDash val="solid"/>
+                      <a:round/>
+                      <a:headEnd type="none" w="med" len="med"/>
+                      <a:tailEnd type="none" w="med" len="med"/>
+                    </a:lnB>
+                    <a:solidFill>
+                      <a:srgbClr val="0B2545"/>
+                    </a:solidFill>
+                  </a:tcPr>
+                </a:tc>
+              </a:tr>
+              <a:tr h="457200">
+                <a:tc>
+                  <a:txBody>
+                    <a:bodyPr/>
+                    <a:lstStyle/>
+                    <a:p>
+                      <a:pPr indent="0" marL="0">
+                        <a:buNone/>
+                      </a:pPr>
+                      <a:r>
+                        <a:rPr lang="en-US" sz="1200" b="1" dirty="0">
+                          <a:solidFill>
+                            <a:srgbClr val="0B2545"/>
+                          </a:solidFill>
+                        </a:rPr>
+                        <a:t>H1 trail 10–15, FG</a:t>
+                      </a:r>
+                      <a:endParaRPr lang="en-US" sz="1200" dirty="0"/>
+                    </a:p>
+                  </a:txBody>
+                  <a:tcPr marL="91440" marR="91440" marT="45720" marB="45720">
+                    <a:lnL w="12700" cap="flat" cmpd="sng" algn="ctr">
+                      <a:solidFill>
+                        <a:srgbClr val="8DA9C4"/>
+                      </a:solidFill>
+                      <a:prstDash val="solid"/>
+                      <a:round/>
+                      <a:headEnd type="none" w="med" len="med"/>
+                      <a:tailEnd type="none" w="med" len="med"/>
+                    </a:lnL>
+                    <a:lnR w="12700" cap="flat" cmpd="sng" algn="ctr">
+                      <a:solidFill>
+                        <a:srgbClr val="8DA9C4"/>
+                      </a:solidFill>
+                      <a:prstDash val="solid"/>
+                      <a:round/>
+                      <a:headEnd type="none" w="med" len="med"/>
+                      <a:tailEnd type="none" w="med" len="med"/>
+                    </a:lnR>
+                    <a:lnT w="12700" cap="flat" cmpd="sng" algn="ctr">
+                      <a:solidFill>
+                        <a:srgbClr val="8DA9C4"/>
+                      </a:solidFill>
+                      <a:prstDash val="solid"/>
+                      <a:round/>
+                      <a:headEnd type="none" w="med" len="med"/>
+                      <a:tailEnd type="none" w="med" len="med"/>
+                    </a:lnT>
+                    <a:lnB w="12700" cap="flat" cmpd="sng" algn="ctr">
+                      <a:solidFill>
+                        <a:srgbClr val="8DA9C4"/>
+                      </a:solidFill>
+                      <a:prstDash val="solid"/>
+                      <a:round/>
+                      <a:headEnd type="none" w="med" len="med"/>
+                      <a:tailEnd type="none" w="med" len="med"/>
+                    </a:lnB>
+                  </a:tcPr>
+                </a:tc>
+                <a:tc>
+                  <a:txBody>
+                    <a:bodyPr/>
+                    <a:lstStyle/>
+                    <a:p>
+                      <a:pPr algn="ctr" indent="0" marL="0">
+                        <a:buNone/>
+                      </a:pPr>
+                      <a:r>
+                        <a:rPr lang="en-US" sz="1300" b="1" dirty="0">
+                          <a:solidFill>
+                            <a:srgbClr val="EEA02B"/>
+                          </a:solidFill>
+                        </a:rPr>
+                        <a:t>+0.0075</a:t>
+                      </a:r>
+                      <a:endParaRPr lang="en-US" sz="1300" dirty="0"/>
+                    </a:p>
+                  </a:txBody>
+                  <a:tcPr marL="91440" marR="91440" marT="45720" marB="45720">
+                    <a:lnL w="12700" cap="flat" cmpd="sng" algn="ctr">
+                      <a:solidFill>
+                        <a:srgbClr val="8DA9C4"/>
+                      </a:solidFill>
+                      <a:prstDash val="solid"/>
+                      <a:round/>
+                      <a:headEnd type="none" w="med" len="med"/>
+                      <a:tailEnd type="none" w="med" len="med"/>
+                    </a:lnL>
+                    <a:lnR w="12700" cap="flat" cmpd="sng" algn="ctr">
+                      <a:solidFill>
+                        <a:srgbClr val="8DA9C4"/>
+                      </a:solidFill>
+                      <a:prstDash val="solid"/>
+                      <a:round/>
+                      <a:headEnd type="none" w="med" len="med"/>
+                      <a:tailEnd type="none" w="med" len="med"/>
+                    </a:lnR>
+                    <a:lnT w="12700" cap="flat" cmpd="sng" algn="ctr">
+                      <a:solidFill>
+                        <a:srgbClr val="8DA9C4"/>
+                      </a:solidFill>
+                      <a:prstDash val="solid"/>
+                      <a:round/>
+                      <a:headEnd type="none" w="med" len="med"/>
+                      <a:tailEnd type="none" w="med" len="med"/>
+                    </a:lnT>
+                    <a:lnB w="12700" cap="flat" cmpd="sng" algn="ctr">
+                      <a:solidFill>
+                        <a:srgbClr val="8DA9C4"/>
+                      </a:solidFill>
+                      <a:prstDash val="solid"/>
+                      <a:round/>
+                      <a:headEnd type="none" w="med" len="med"/>
+                      <a:tailEnd type="none" w="med" len="med"/>
+                    </a:lnB>
+                  </a:tcPr>
+                </a:tc>
+                <a:tc>
+                  <a:txBody>
+                    <a:bodyPr/>
+                    <a:lstStyle/>
+                    <a:p>
+                      <a:pPr algn="ctr" indent="0" marL="0">
+                        <a:buNone/>
+                      </a:pPr>
+                      <a:r>
+                        <a:rPr lang="en-US" sz="1300" b="1" dirty="0">
+                          <a:solidFill>
+                            <a:srgbClr val="EEA02B"/>
+                          </a:solidFill>
+                        </a:rPr>
+                        <a:t>&lt; 0.0001</a:t>
+                      </a:r>
+                      <a:endParaRPr lang="en-US" sz="1300" dirty="0"/>
+                    </a:p>
+                  </a:txBody>
+                  <a:tcPr marL="91440" marR="91440" marT="45720" marB="45720">
+                    <a:lnL w="12700" cap="flat" cmpd="sng" algn="ctr">
+                      <a:solidFill>
+                        <a:srgbClr val="8DA9C4"/>
+                      </a:solidFill>
+                      <a:prstDash val="solid"/>
+                      <a:round/>
+                      <a:headEnd type="none" w="med" len="med"/>
+                      <a:tailEnd type="none" w="med" len="med"/>
+                    </a:lnL>
+                    <a:lnR w="12700" cap="flat" cmpd="sng" algn="ctr">
+                      <a:solidFill>
+                        <a:srgbClr val="8DA9C4"/>
+                      </a:solidFill>
+                      <a:prstDash val="solid"/>
+                      <a:round/>
+                      <a:headEnd type="none" w="med" len="med"/>
+                      <a:tailEnd type="none" w="med" len="med"/>
+                    </a:lnR>
+                    <a:lnT w="12700" cap="flat" cmpd="sng" algn="ctr">
+                      <a:solidFill>
+                        <a:srgbClr val="8DA9C4"/>
+                      </a:solidFill>
+                      <a:prstDash val="solid"/>
+                      <a:round/>
+                      <a:headEnd type="none" w="med" len="med"/>
+                      <a:tailEnd type="none" w="med" len="med"/>
+                    </a:lnT>
+                    <a:lnB w="12700" cap="flat" cmpd="sng" algn="ctr">
+                      <a:solidFill>
+                        <a:srgbClr val="8DA9C4"/>
+                      </a:solidFill>
+                      <a:prstDash val="solid"/>
+                      <a:round/>
+                      <a:headEnd type="none" w="med" len="med"/>
+                      <a:tailEnd type="none" w="med" len="med"/>
+                    </a:lnB>
+                  </a:tcPr>
+                </a:tc>
+              </a:tr>
+              <a:tr h="457200">
+                <a:tc>
+                  <a:txBody>
+                    <a:bodyPr/>
+                    <a:lstStyle/>
+                    <a:p>
+                      <a:pPr indent="0" marL="0">
+                        <a:buNone/>
+                      </a:pPr>
+                      <a:r>
+                        <a:rPr lang="en-US" sz="1200" b="1" dirty="0">
+                          <a:solidFill>
+                            <a:srgbClr val="0B2545"/>
+                          </a:solidFill>
+                        </a:rPr>
+                        <a:t>H4 trail ≥10, 3PT</a:t>
+                      </a:r>
+                      <a:endParaRPr lang="en-US" sz="1200" dirty="0"/>
+                    </a:p>
+                  </a:txBody>
+                  <a:tcPr marL="91440" marR="91440" marT="45720" marB="45720">
+                    <a:lnL w="12700" cap="flat" cmpd="sng" algn="ctr">
+                      <a:solidFill>
+                        <a:srgbClr val="8DA9C4"/>
+                      </a:solidFill>
+                      <a:prstDash val="solid"/>
+                      <a:round/>
+                      <a:headEnd type="none" w="med" len="med"/>
+                      <a:tailEnd type="none" w="med" len="med"/>
+                    </a:lnL>
+                    <a:lnR w="12700" cap="flat" cmpd="sng" algn="ctr">
+                      <a:solidFill>
+                        <a:srgbClr val="8DA9C4"/>
+                      </a:solidFill>
+                      <a:prstDash val="solid"/>
+                      <a:round/>
+                      <a:headEnd type="none" w="med" len="med"/>
+                      <a:tailEnd type="none" w="med" len="med"/>
+                    </a:lnR>
+                    <a:lnT w="12700" cap="flat" cmpd="sng" algn="ctr">
+                      <a:solidFill>
+                        <a:srgbClr val="8DA9C4"/>
+                      </a:solidFill>
+                      <a:prstDash val="solid"/>
+                      <a:round/>
+                      <a:headEnd type="none" w="med" len="med"/>
+                      <a:tailEnd type="none" w="med" len="med"/>
+                    </a:lnT>
+                    <a:lnB w="12700" cap="flat" cmpd="sng" algn="ctr">
+                      <a:solidFill>
+                        <a:srgbClr val="8DA9C4"/>
+                      </a:solidFill>
+                      <a:prstDash val="solid"/>
+                      <a:round/>
+                      <a:headEnd type="none" w="med" len="med"/>
+                      <a:tailEnd type="none" w="med" len="med"/>
+                    </a:lnB>
+                  </a:tcPr>
+                </a:tc>
+                <a:tc>
+                  <a:txBody>
+                    <a:bodyPr/>
+                    <a:lstStyle/>
+                    <a:p>
+                      <a:pPr algn="ctr" indent="0" marL="0">
+                        <a:buNone/>
+                      </a:pPr>
+                      <a:r>
+                        <a:rPr lang="en-US" sz="1300" b="1" dirty="0">
+                          <a:solidFill>
+                            <a:srgbClr val="EEA02B"/>
+                          </a:solidFill>
+                        </a:rPr>
+                        <a:t>+0.0138</a:t>
+                      </a:r>
+                      <a:endParaRPr lang="en-US" sz="1300" dirty="0"/>
+                    </a:p>
+                  </a:txBody>
+                  <a:tcPr marL="91440" marR="91440" marT="45720" marB="45720">
+                    <a:lnL w="12700" cap="flat" cmpd="sng" algn="ctr">
+                      <a:solidFill>
+                        <a:srgbClr val="8DA9C4"/>
+                      </a:solidFill>
+                      <a:prstDash val="solid"/>
+                      <a:round/>
+                      <a:headEnd type="none" w="med" len="med"/>
+                      <a:tailEnd type="none" w="med" len="med"/>
+                    </a:lnL>
+                    <a:lnR w="12700" cap="flat" cmpd="sng" algn="ctr">
+                      <a:solidFill>
+                        <a:srgbClr val="8DA9C4"/>
+                      </a:solidFill>
+                      <a:prstDash val="solid"/>
+                      <a:round/>
+                      <a:headEnd type="none" w="med" len="med"/>
+                      <a:tailEnd type="none" w="med" len="med"/>
+                    </a:lnR>
+                    <a:lnT w="12700" cap="flat" cmpd="sng" algn="ctr">
+                      <a:solidFill>
+                        <a:srgbClr val="8DA9C4"/>
+                      </a:solidFill>
+                      <a:prstDash val="solid"/>
+                      <a:round/>
+                      <a:headEnd type="none" w="med" len="med"/>
+                      <a:tailEnd type="none" w="med" len="med"/>
+                    </a:lnT>
+                    <a:lnB w="12700" cap="flat" cmpd="sng" algn="ctr">
+                      <a:solidFill>
+                        <a:srgbClr val="8DA9C4"/>
+                      </a:solidFill>
+                      <a:prstDash val="solid"/>
+                      <a:round/>
+                      <a:headEnd type="none" w="med" len="med"/>
+                      <a:tailEnd type="none" w="med" len="med"/>
+                    </a:lnB>
+                  </a:tcPr>
+                </a:tc>
+                <a:tc>
+                  <a:txBody>
+                    <a:bodyPr/>
+                    <a:lstStyle/>
+                    <a:p>
+                      <a:pPr algn="ctr" indent="0" marL="0">
+                        <a:buNone/>
+                      </a:pPr>
+                      <a:r>
+                        <a:rPr lang="en-US" sz="1300" b="1" dirty="0">
+                          <a:solidFill>
+                            <a:srgbClr val="EEA02B"/>
+                          </a:solidFill>
+                        </a:rPr>
+                        <a:t>&lt; 0.0001</a:t>
+                      </a:r>
+                      <a:endParaRPr lang="en-US" sz="1300" dirty="0"/>
+                    </a:p>
+                  </a:txBody>
+                  <a:tcPr marL="91440" marR="91440" marT="45720" marB="45720">
+                    <a:lnL w="12700" cap="flat" cmpd="sng" algn="ctr">
+                      <a:solidFill>
+                        <a:srgbClr val="8DA9C4"/>
+                      </a:solidFill>
+                      <a:prstDash val="solid"/>
+                      <a:round/>
+                      <a:headEnd type="none" w="med" len="med"/>
+                      <a:tailEnd type="none" w="med" len="med"/>
+                    </a:lnL>
+                    <a:lnR w="12700" cap="flat" cmpd="sng" algn="ctr">
+                      <a:solidFill>
+                        <a:srgbClr val="8DA9C4"/>
+                      </a:solidFill>
+                      <a:prstDash val="solid"/>
+                      <a:round/>
+                      <a:headEnd type="none" w="med" len="med"/>
+                      <a:tailEnd type="none" w="med" len="med"/>
+                    </a:lnR>
+                    <a:lnT w="12700" cap="flat" cmpd="sng" algn="ctr">
+                      <a:solidFill>
+                        <a:srgbClr val="8DA9C4"/>
+                      </a:solidFill>
+                      <a:prstDash val="solid"/>
+                      <a:round/>
+                      <a:headEnd type="none" w="med" len="med"/>
+                      <a:tailEnd type="none" w="med" len="med"/>
+                    </a:lnT>
+                    <a:lnB w="12700" cap="flat" cmpd="sng" algn="ctr">
+                      <a:solidFill>
+                        <a:srgbClr val="8DA9C4"/>
+                      </a:solidFill>
+                      <a:prstDash val="solid"/>
+                      <a:round/>
+                      <a:headEnd type="none" w="med" len="med"/>
+                      <a:tailEnd type="none" w="med" len="med"/>
+                    </a:lnB>
+                  </a:tcPr>
+                </a:tc>
+              </a:tr>
+            </a:tbl>
+          </a:graphicData>
+        </a:graphic>
+      </p:graphicFrame>
+      <p:sp>
+        <p:nvSpPr>
+          <p:cNvPr id="10" name="Text 7"/>
+          <p:cNvSpPr/>
+          <p:nvPr/>
+        </p:nvSpPr>
+        <p:spPr>
+          <a:xfrm>
+            <a:off x="685800" y="4617720"/>
+            <a:ext cx="5120640" cy="320040"/>
+          </a:xfrm>
+          <a:prstGeom prst="rect">
+            <a:avLst/>
+          </a:prstGeom>
+          <a:noFill/>
+          <a:ln/>
+        </p:spPr>
+        <p:txBody>
+          <a:bodyPr wrap="square" rtlCol="0" anchor="ctr"/>
+          <a:lstStyle/>
+          <a:p>
+            <a:pPr indent="0" marL="0">
+              <a:buNone/>
+            </a:pPr>
+            <a:r>
+              <a:rPr lang="en-US" sz="1200" i="1" dirty="0">
+                <a:solidFill>
+                  <a:srgbClr val="13315C"/>
+                </a:solidFill>
+                <a:latin typeface="Calibri" pitchFamily="34" charset="0"/>
+                <a:ea typeface="Calibri" pitchFamily="34" charset="-122"/>
+                <a:cs typeface="Calibri" pitchFamily="34" charset="-120"/>
+              </a:rPr>
+              <a:t>Both pre-registered tests pass on 2024-25 held-out.</a:t>
+            </a:r>
+            <a:endParaRPr lang="en-US" sz="1200" dirty="0"/>
+          </a:p>
+        </p:txBody>
+      </p:sp>
+      <p:sp>
+        <p:nvSpPr>
+          <p:cNvPr id="11" name="Text 8"/>
+          <p:cNvSpPr/>
+          <p:nvPr/>
+        </p:nvSpPr>
+        <p:spPr>
+          <a:xfrm>
+            <a:off x="685800" y="4937760"/>
+            <a:ext cx="5120640" cy="411480"/>
+          </a:xfrm>
+          <a:prstGeom prst="rect">
+            <a:avLst/>
+          </a:prstGeom>
+          <a:noFill/>
+          <a:ln/>
+        </p:spPr>
+        <p:txBody>
+          <a:bodyPr wrap="square" rtlCol="0" anchor="ctr"/>
+          <a:lstStyle/>
+          <a:p>
+            <a:pPr indent="0" marL="0">
+              <a:buNone/>
+            </a:pPr>
+            <a:r>
+              <a:rPr lang="en-US" sz="1200" i="1" dirty="0">
+                <a:solidFill>
+                  <a:srgbClr val="13315C"/>
+                </a:solidFill>
+                <a:latin typeface="Calibri" pitchFamily="34" charset="0"/>
+                <a:ea typeface="Calibri" pitchFamily="34" charset="-122"/>
+                <a:cs typeface="Calibri" pitchFamily="34" charset="-120"/>
+              </a:rPr>
+              <a:t>V2 calibration backs it (Brier 0.149); V1 / V3 / V4 / V6 not powered yet.</a:t>
+            </a:r>
+            <a:endParaRPr lang="en-US" sz="1200" dirty="0"/>
+          </a:p>
+        </p:txBody>
+      </p:sp>
+      <p:sp>
+        <p:nvSpPr>
+          <p:cNvPr id="12" name="Shape 9"/>
+          <p:cNvSpPr/>
+          <p:nvPr/>
+        </p:nvSpPr>
+        <p:spPr>
+          <a:xfrm>
+            <a:off x="685800" y="5486400"/>
+            <a:ext cx="5120640" cy="640080"/>
+          </a:xfrm>
+          <a:prstGeom prst="rect">
+            <a:avLst/>
+          </a:prstGeom>
+          <a:solidFill>
+            <a:srgbClr val="0B2545"/>
+          </a:solidFill>
+          <a:ln w="12700">
+            <a:solidFill>
+              <a:srgbClr val="0B2545"/>
+            </a:solidFill>
+            <a:prstDash val="solid"/>
+          </a:ln>
+        </p:spPr>
+      </p:sp>
+      <p:sp>
+        <p:nvSpPr>
+          <p:cNvPr id="13" name="Text 10"/>
+          <p:cNvSpPr/>
+          <p:nvPr/>
+        </p:nvSpPr>
+        <p:spPr>
+          <a:xfrm>
+            <a:off x="685800" y="5486400"/>
+            <a:ext cx="5120640" cy="640080"/>
+          </a:xfrm>
+          <a:prstGeom prst="rect">
+            <a:avLst/>
+          </a:prstGeom>
+          <a:noFill/>
+          <a:ln/>
+        </p:spPr>
+        <p:txBody>
+          <a:bodyPr wrap="square" rtlCol="0" anchor="ctr"/>
+          <a:lstStyle/>
+          <a:p>
+            <a:pPr algn="ctr" indent="0" marL="0">
+              <a:buNone/>
+            </a:pPr>
+            <a:r>
+              <a:rPr lang="en-US" sz="1500" b="1" i="1" dirty="0">
+                <a:solidFill>
+                  <a:srgbClr val="F6F6F2"/>
+                </a:solidFill>
+                <a:latin typeface="Georgia" pitchFamily="34" charset="0"/>
+                <a:ea typeface="Georgia" pitchFamily="34" charset="-122"/>
+                <a:cs typeface="Georgia" pitchFamily="34" charset="-120"/>
+              </a:rPr>
+              <a:t>The bias is statistically real.</a:t>
+            </a:r>
+            <a:endParaRPr lang="en-US" sz="1500" dirty="0"/>
+          </a:p>
+        </p:txBody>
+      </p:sp>
+      <p:sp>
+        <p:nvSpPr>
+          <p:cNvPr id="14" name="Shape 11"/>
+          <p:cNvSpPr/>
+          <p:nvPr/>
+        </p:nvSpPr>
+        <p:spPr>
+          <a:xfrm>
+            <a:off x="6263640" y="1417320"/>
+            <a:ext cx="5486400" cy="4846320"/>
+          </a:xfrm>
+          <a:prstGeom prst="roundRect">
+            <a:avLst>
+              <a:gd name="adj" fmla="val 1887"/>
+            </a:avLst>
+          </a:prstGeom>
+          <a:solidFill>
+            <a:srgbClr val="F6F6F2"/>
+          </a:solidFill>
+          <a:ln w="19050">
+            <a:solidFill>
+              <a:srgbClr val="EEA02B"/>
+            </a:solidFill>
+            <a:prstDash val="solid"/>
+          </a:ln>
+        </p:spPr>
+      </p:sp>
+      <p:sp>
+        <p:nvSpPr>
+          <p:cNvPr id="15" name="Text 12"/>
+          <p:cNvSpPr/>
+          <p:nvPr/>
+        </p:nvSpPr>
+        <p:spPr>
+          <a:xfrm>
+            <a:off x="6446520" y="1554480"/>
+            <a:ext cx="5120640" cy="365760"/>
+          </a:xfrm>
+          <a:prstGeom prst="rect">
+            <a:avLst/>
+          </a:prstGeom>
+          <a:noFill/>
+          <a:ln/>
+        </p:spPr>
+        <p:txBody>
+          <a:bodyPr wrap="square" rtlCol="0" anchor="ctr"/>
+          <a:lstStyle/>
+          <a:p>
+            <a:pPr indent="0" marL="0">
+              <a:buNone/>
+            </a:pPr>
+            <a:r>
+              <a:rPr lang="en-US" sz="1200" b="1" dirty="0">
+                <a:solidFill>
+                  <a:srgbClr val="13315C"/>
+                </a:solidFill>
+                <a:latin typeface="Calibri" pitchFamily="34" charset="0"/>
+                <a:ea typeface="Calibri" pitchFamily="34" charset="-122"/>
+                <a:cs typeface="Calibri" pitchFamily="34" charset="-120"/>
+              </a:rPr>
+              <a:t>CAN IT MAKE MONEY?</a:t>
+            </a:r>
+            <a:endParaRPr lang="en-US" sz="1200" dirty="0"/>
+          </a:p>
+        </p:txBody>
+      </p:sp>
+      <p:sp>
+        <p:nvSpPr>
+          <p:cNvPr id="16" name="Text 13"/>
+          <p:cNvSpPr/>
+          <p:nvPr/>
+        </p:nvSpPr>
+        <p:spPr>
+          <a:xfrm>
+            <a:off x="6446520" y="1920240"/>
+            <a:ext cx="5120640" cy="502920"/>
+          </a:xfrm>
+          <a:prstGeom prst="rect">
+            <a:avLst/>
+          </a:prstGeom>
+          <a:noFill/>
+          <a:ln/>
+        </p:spPr>
+        <p:txBody>
+          <a:bodyPr wrap="square" rtlCol="0" anchor="ctr"/>
+          <a:lstStyle/>
+          <a:p>
+            <a:pPr indent="0" marL="0">
+              <a:buNone/>
+            </a:pPr>
+            <a:r>
+              <a:rPr lang="en-US" sz="2000" b="1" dirty="0">
+                <a:solidFill>
+                  <a:srgbClr val="0B2545"/>
+                </a:solidFill>
+                <a:latin typeface="Georgia" pitchFamily="34" charset="0"/>
+                <a:ea typeface="Georgia" pitchFamily="34" charset="-122"/>
+                <a:cs typeface="Georgia" pitchFamily="34" charset="-120"/>
+              </a:rPr>
+              <a:t>Not yet — but it's not 'no.'</a:t>
+            </a:r>
+            <a:endParaRPr lang="en-US" sz="2000" dirty="0"/>
+          </a:p>
+        </p:txBody>
+      </p:sp>
+      <p:sp>
+        <p:nvSpPr>
+          <p:cNvPr id="17" name="Shape 14"/>
+          <p:cNvSpPr/>
+          <p:nvPr/>
+        </p:nvSpPr>
+        <p:spPr>
+          <a:xfrm>
+            <a:off x="6446520" y="2606040"/>
+            <a:ext cx="164592" cy="777240"/>
+          </a:xfrm>
+          <a:prstGeom prst="rect">
             <a:avLst/>
           </a:prstGeom>
           <a:solidFill>
@@ -4279,14 +5238,323 @@
       </p:sp>
       <p:sp>
         <p:nvSpPr>
-          <p:cNvPr id="6" name="Text 4"/>
-          <p:cNvSpPr/>
-          <p:nvPr/>
-        </p:nvSpPr>
-        <p:spPr>
-          <a:xfrm>
-            <a:off x="502920" y="1572768"/>
-            <a:ext cx="457200" cy="457200"/>
+          <p:cNvPr id="18" name="Text 15"/>
+          <p:cNvSpPr/>
+          <p:nvPr/>
+        </p:nvSpPr>
+        <p:spPr>
+          <a:xfrm>
+            <a:off x="6675120" y="2606040"/>
+            <a:ext cx="4846320" cy="274320"/>
+          </a:xfrm>
+          <a:prstGeom prst="rect">
+            <a:avLst/>
+          </a:prstGeom>
+          <a:noFill/>
+          <a:ln/>
+        </p:spPr>
+        <p:txBody>
+          <a:bodyPr wrap="square" rtlCol="0" anchor="ctr"/>
+          <a:lstStyle/>
+          <a:p>
+            <a:pPr indent="0" marL="0">
+              <a:buNone/>
+            </a:pPr>
+            <a:r>
+              <a:rPr lang="en-US" sz="1100" b="1" dirty="0">
+                <a:solidFill>
+                  <a:srgbClr val="EEA02B"/>
+                </a:solidFill>
+                <a:latin typeface="Calibri" pitchFamily="34" charset="0"/>
+                <a:ea typeface="Calibri" pitchFamily="34" charset="-122"/>
+                <a:cs typeface="Calibri" pitchFamily="34" charset="-120"/>
+              </a:rPr>
+              <a:t>TODAY · NO</a:t>
+            </a:r>
+            <a:endParaRPr lang="en-US" sz="1100" dirty="0"/>
+          </a:p>
+        </p:txBody>
+      </p:sp>
+      <p:sp>
+        <p:nvSpPr>
+          <p:cNvPr id="19" name="Text 16"/>
+          <p:cNvSpPr/>
+          <p:nvPr/>
+        </p:nvSpPr>
+        <p:spPr>
+          <a:xfrm>
+            <a:off x="6675120" y="2880360"/>
+            <a:ext cx="4846320" cy="548640"/>
+          </a:xfrm>
+          <a:prstGeom prst="rect">
+            <a:avLst/>
+          </a:prstGeom>
+          <a:noFill/>
+          <a:ln/>
+        </p:spPr>
+        <p:txBody>
+          <a:bodyPr wrap="square" rtlCol="0" anchor="ctr"/>
+          <a:lstStyle/>
+          <a:p>
+            <a:pPr indent="0" marL="0">
+              <a:buNone/>
+            </a:pPr>
+            <a:r>
+              <a:rPr lang="en-US" sz="1200" dirty="0">
+                <a:solidFill>
+                  <a:srgbClr val="1A1A1A"/>
+                </a:solidFill>
+                <a:latin typeface="Calibri" pitchFamily="34" charset="0"/>
+                <a:ea typeface="Calibri" pitchFamily="34" charset="-122"/>
+                <a:cs typeface="Calibri" pitchFamily="34" charset="-120"/>
+              </a:rPr>
+              <a:t>Live game vs liquid books: n=1 → −40% (noise). Kalshi +95% = stale-mid artifact.</a:t>
+            </a:r>
+            <a:endParaRPr lang="en-US" sz="1200" dirty="0"/>
+          </a:p>
+        </p:txBody>
+      </p:sp>
+      <p:sp>
+        <p:nvSpPr>
+          <p:cNvPr id="20" name="Shape 17"/>
+          <p:cNvSpPr/>
+          <p:nvPr/>
+        </p:nvSpPr>
+        <p:spPr>
+          <a:xfrm>
+            <a:off x="6446520" y="3474720"/>
+            <a:ext cx="164592" cy="777240"/>
+          </a:xfrm>
+          <a:prstGeom prst="rect">
+            <a:avLst/>
+          </a:prstGeom>
+          <a:solidFill>
+            <a:srgbClr val="0B2545"/>
+          </a:solidFill>
+          <a:ln w="12700">
+            <a:solidFill>
+              <a:srgbClr val="0B2545"/>
+            </a:solidFill>
+            <a:prstDash val="solid"/>
+          </a:ln>
+        </p:spPr>
+      </p:sp>
+      <p:sp>
+        <p:nvSpPr>
+          <p:cNvPr id="21" name="Text 18"/>
+          <p:cNvSpPr/>
+          <p:nvPr/>
+        </p:nvSpPr>
+        <p:spPr>
+          <a:xfrm>
+            <a:off x="6675120" y="3474720"/>
+            <a:ext cx="4846320" cy="274320"/>
+          </a:xfrm>
+          <a:prstGeom prst="rect">
+            <a:avLst/>
+          </a:prstGeom>
+          <a:noFill/>
+          <a:ln/>
+        </p:spPr>
+        <p:txBody>
+          <a:bodyPr wrap="square" rtlCol="0" anchor="ctr"/>
+          <a:lstStyle/>
+          <a:p>
+            <a:pPr indent="0" marL="0">
+              <a:buNone/>
+            </a:pPr>
+            <a:r>
+              <a:rPr lang="en-US" sz="1100" b="1" dirty="0">
+                <a:solidFill>
+                  <a:srgbClr val="0B2545"/>
+                </a:solidFill>
+                <a:latin typeface="Calibri" pitchFamily="34" charset="0"/>
+                <a:ea typeface="Calibri" pitchFamily="34" charset="-122"/>
+                <a:cs typeface="Calibri" pitchFamily="34" charset="-120"/>
+              </a:rPr>
+              <a:t>BIAS · YES</a:t>
+            </a:r>
+            <a:endParaRPr lang="en-US" sz="1100" dirty="0"/>
+          </a:p>
+        </p:txBody>
+      </p:sp>
+      <p:sp>
+        <p:nvSpPr>
+          <p:cNvPr id="22" name="Text 19"/>
+          <p:cNvSpPr/>
+          <p:nvPr/>
+        </p:nvSpPr>
+        <p:spPr>
+          <a:xfrm>
+            <a:off x="6675120" y="3749040"/>
+            <a:ext cx="4846320" cy="548640"/>
+          </a:xfrm>
+          <a:prstGeom prst="rect">
+            <a:avLst/>
+          </a:prstGeom>
+          <a:noFill/>
+          <a:ln/>
+        </p:spPr>
+        <p:txBody>
+          <a:bodyPr wrap="square" rtlCol="0" anchor="ctr"/>
+          <a:lstStyle/>
+          <a:p>
+            <a:pPr indent="0" marL="0">
+              <a:buNone/>
+            </a:pPr>
+            <a:r>
+              <a:rPr lang="en-US" sz="1200" dirty="0">
+                <a:solidFill>
+                  <a:srgbClr val="1A1A1A"/>
+                </a:solidFill>
+                <a:latin typeface="Calibri" pitchFamily="34" charset="0"/>
+                <a:ea typeface="Calibri" pitchFamily="34" charset="-122"/>
+                <a:cs typeface="Calibri" pitchFamily="34" charset="-120"/>
+              </a:rPr>
+              <a:t>V5 H1/H4 pre-reg passed on the held-out season. The overreaction is real.</a:t>
+            </a:r>
+            <a:endParaRPr lang="en-US" sz="1200" dirty="0"/>
+          </a:p>
+        </p:txBody>
+      </p:sp>
+      <p:sp>
+        <p:nvSpPr>
+          <p:cNvPr id="23" name="Shape 20"/>
+          <p:cNvSpPr/>
+          <p:nvPr/>
+        </p:nvSpPr>
+        <p:spPr>
+          <a:xfrm>
+            <a:off x="6446520" y="4343400"/>
+            <a:ext cx="164592" cy="777240"/>
+          </a:xfrm>
+          <a:prstGeom prst="rect">
+            <a:avLst/>
+          </a:prstGeom>
+          <a:solidFill>
+            <a:srgbClr val="1C7293"/>
+          </a:solidFill>
+          <a:ln w="12700">
+            <a:solidFill>
+              <a:srgbClr val="1C7293"/>
+            </a:solidFill>
+            <a:prstDash val="solid"/>
+          </a:ln>
+        </p:spPr>
+      </p:sp>
+      <p:sp>
+        <p:nvSpPr>
+          <p:cNvPr id="24" name="Text 21"/>
+          <p:cNvSpPr/>
+          <p:nvPr/>
+        </p:nvSpPr>
+        <p:spPr>
+          <a:xfrm>
+            <a:off x="6675120" y="4343400"/>
+            <a:ext cx="4846320" cy="274320"/>
+          </a:xfrm>
+          <a:prstGeom prst="rect">
+            <a:avLst/>
+          </a:prstGeom>
+          <a:noFill/>
+          <a:ln/>
+        </p:spPr>
+        <p:txBody>
+          <a:bodyPr wrap="square" rtlCol="0" anchor="ctr"/>
+          <a:lstStyle/>
+          <a:p>
+            <a:pPr indent="0" marL="0">
+              <a:buNone/>
+            </a:pPr>
+            <a:r>
+              <a:rPr lang="en-US" sz="1100" b="1" dirty="0">
+                <a:solidFill>
+                  <a:srgbClr val="1C7293"/>
+                </a:solidFill>
+                <a:latin typeface="Calibri" pitchFamily="34" charset="0"/>
+                <a:ea typeface="Calibri" pitchFamily="34" charset="-122"/>
+                <a:cs typeface="Calibri" pitchFamily="34" charset="-120"/>
+              </a:rPr>
+              <a:t>PATH · CLEAR</a:t>
+            </a:r>
+            <a:endParaRPr lang="en-US" sz="1100" dirty="0"/>
+          </a:p>
+        </p:txBody>
+      </p:sp>
+      <p:sp>
+        <p:nvSpPr>
+          <p:cNvPr id="25" name="Text 22"/>
+          <p:cNvSpPr/>
+          <p:nvPr/>
+        </p:nvSpPr>
+        <p:spPr>
+          <a:xfrm>
+            <a:off x="6675120" y="4617720"/>
+            <a:ext cx="4846320" cy="548640"/>
+          </a:xfrm>
+          <a:prstGeom prst="rect">
+            <a:avLst/>
+          </a:prstGeom>
+          <a:noFill/>
+          <a:ln/>
+        </p:spPr>
+        <p:txBody>
+          <a:bodyPr wrap="square" rtlCol="0" anchor="ctr"/>
+          <a:lstStyle/>
+          <a:p>
+            <a:pPr indent="0" marL="0">
+              <a:buNone/>
+            </a:pPr>
+            <a:r>
+              <a:rPr lang="en-US" sz="1200" dirty="0">
+                <a:solidFill>
+                  <a:srgbClr val="1A1A1A"/>
+                </a:solidFill>
+                <a:latin typeface="Calibri" pitchFamily="34" charset="0"/>
+                <a:ea typeface="Calibri" pitchFamily="34" charset="-122"/>
+                <a:cs typeface="Calibri" pitchFamily="34" charset="-120"/>
+              </a:rPr>
+              <a:t>Power the backtest ($59 historical) → V5-targeted strategy on Kalshi (legal, no limits).</a:t>
+            </a:r>
+            <a:endParaRPr lang="en-US" sz="1200" dirty="0"/>
+          </a:p>
+        </p:txBody>
+      </p:sp>
+      <p:sp>
+        <p:nvSpPr>
+          <p:cNvPr id="26" name="Shape 23"/>
+          <p:cNvSpPr/>
+          <p:nvPr/>
+        </p:nvSpPr>
+        <p:spPr>
+          <a:xfrm>
+            <a:off x="6446520" y="5486400"/>
+            <a:ext cx="5120640" cy="640080"/>
+          </a:xfrm>
+          <a:prstGeom prst="rect">
+            <a:avLst/>
+          </a:prstGeom>
+          <a:solidFill>
+            <a:srgbClr val="0B2545"/>
+          </a:solidFill>
+          <a:ln w="12700">
+            <a:solidFill>
+              <a:srgbClr val="0B2545"/>
+            </a:solidFill>
+            <a:prstDash val="solid"/>
+          </a:ln>
+        </p:spPr>
+      </p:sp>
+      <p:sp>
+        <p:nvSpPr>
+          <p:cNvPr id="27" name="Text 24"/>
+          <p:cNvSpPr/>
+          <p:nvPr/>
+        </p:nvSpPr>
+        <p:spPr>
+          <a:xfrm>
+            <a:off x="6446520" y="5486400"/>
+            <a:ext cx="5120640" cy="640080"/>
           </a:xfrm>
           <a:prstGeom prst="rect">
             <a:avLst/>
@@ -4302,69 +5570,69 @@
               <a:buNone/>
             </a:pPr>
             <a:r>
-              <a:rPr lang="en-US" sz="1600" b="1" dirty="0">
-                <a:solidFill>
-                  <a:srgbClr val="0B2545"/>
+              <a:rPr lang="en-US" sz="1500" b="1" i="1" dirty="0">
+                <a:solidFill>
+                  <a:srgbClr val="F6F6F2"/>
                 </a:solidFill>
                 <a:latin typeface="Georgia" pitchFamily="34" charset="0"/>
                 <a:ea typeface="Georgia" pitchFamily="34" charset="-122"/>
                 <a:cs typeface="Georgia" pitchFamily="34" charset="-120"/>
               </a:rPr>
-              <a:t>1</a:t>
-            </a:r>
-            <a:endParaRPr lang="en-US" sz="1600" dirty="0"/>
-          </a:p>
-        </p:txBody>
-      </p:sp>
-      <p:sp>
-        <p:nvSpPr>
-          <p:cNvPr id="7" name="Text 5"/>
-          <p:cNvSpPr/>
-          <p:nvPr/>
-        </p:nvSpPr>
-        <p:spPr>
-          <a:xfrm>
-            <a:off x="1143000" y="1508760"/>
-            <a:ext cx="10972800" cy="411480"/>
-          </a:xfrm>
-          <a:prstGeom prst="rect">
-            <a:avLst/>
-          </a:prstGeom>
-          <a:noFill/>
-          <a:ln/>
-        </p:spPr>
-        <p:txBody>
-          <a:bodyPr wrap="square" rtlCol="0" anchor="ctr"/>
-          <a:lstStyle/>
-          <a:p>
-            <a:pPr indent="0" marL="0">
-              <a:buNone/>
-            </a:pPr>
-            <a:r>
-              <a:rPr lang="en-US" sz="1700" b="1" dirty="0">
-                <a:solidFill>
-                  <a:srgbClr val="0B2545"/>
+              <a:t>Gated on data scale, not on methodology.</a:t>
+            </a:r>
+            <a:endParaRPr lang="en-US" sz="1500" dirty="0"/>
+          </a:p>
+        </p:txBody>
+      </p:sp>
+      <p:sp>
+        <p:nvSpPr>
+          <p:cNvPr id="28" name="Text 25"/>
+          <p:cNvSpPr/>
+          <p:nvPr/>
+        </p:nvSpPr>
+        <p:spPr>
+          <a:xfrm>
+            <a:off x="502920" y="6355080"/>
+            <a:ext cx="11247120" cy="365760"/>
+          </a:xfrm>
+          <a:prstGeom prst="rect">
+            <a:avLst/>
+          </a:prstGeom>
+          <a:noFill/>
+          <a:ln/>
+        </p:spPr>
+        <p:txBody>
+          <a:bodyPr wrap="square" rtlCol="0" anchor="ctr"/>
+          <a:lstStyle/>
+          <a:p>
+            <a:pPr algn="ctr" indent="0" marL="0">
+              <a:buNone/>
+            </a:pPr>
+            <a:r>
+              <a:rPr lang="en-US" sz="1800" b="1" i="1" dirty="0">
+                <a:solidFill>
+                  <a:srgbClr val="1C7293"/>
                 </a:solidFill>
                 <a:latin typeface="Georgia" pitchFamily="34" charset="0"/>
                 <a:ea typeface="Georgia" pitchFamily="34" charset="-122"/>
                 <a:cs typeface="Georgia" pitchFamily="34" charset="-120"/>
               </a:rPr>
-              <a:t>Calibrated WP model</a:t>
-            </a:r>
-            <a:endParaRPr lang="en-US" sz="1700" dirty="0"/>
-          </a:p>
-        </p:txBody>
-      </p:sp>
-      <p:sp>
-        <p:nvSpPr>
-          <p:cNvPr id="8" name="Text 6"/>
-          <p:cNvSpPr/>
-          <p:nvPr/>
-        </p:nvSpPr>
-        <p:spPr>
-          <a:xfrm>
-            <a:off x="1143000" y="1920240"/>
-            <a:ext cx="10972800" cy="548640"/>
+              <a:t>Thank you. Questions?</a:t>
+            </a:r>
+            <a:endParaRPr lang="en-US" sz="1800" dirty="0"/>
+          </a:p>
+        </p:txBody>
+      </p:sp>
+      <p:sp>
+        <p:nvSpPr>
+          <p:cNvPr id="29" name="Text 26"/>
+          <p:cNvSpPr/>
+          <p:nvPr/>
+        </p:nvSpPr>
+        <p:spPr>
+          <a:xfrm>
+            <a:off x="502920" y="6492240"/>
+            <a:ext cx="7315200" cy="274320"/>
           </a:xfrm>
           <a:prstGeom prst="rect">
             <a:avLst/>
@@ -4380,660 +5648,14 @@
               <a:buNone/>
             </a:pPr>
             <a:r>
-              <a:rPr lang="en-US" sz="1400" dirty="0">
-                <a:solidFill>
-                  <a:srgbClr val="1A1A1A"/>
+              <a:rPr lang="en-US" sz="1000" dirty="0">
+                <a:solidFill>
+                  <a:srgbClr val="8DA9C4"/>
                 </a:solidFill>
                 <a:latin typeface="Calibri" pitchFamily="34" charset="0"/>
                 <a:ea typeface="Calibri" pitchFamily="34" charset="-122"/>
                 <a:cs typeface="Calibri" pitchFamily="34" charset="-120"/>
               </a:rPr>
-              <a:t>Brier 0.149 OOS · ECE 0.008 — simple, defensible artifact.</a:t>
-            </a:r>
-            <a:endParaRPr lang="en-US" sz="1400" dirty="0"/>
-          </a:p>
-        </p:txBody>
-      </p:sp>
-      <p:sp>
-        <p:nvSpPr>
-          <p:cNvPr id="9" name="Shape 7"/>
-          <p:cNvSpPr/>
-          <p:nvPr/>
-        </p:nvSpPr>
-        <p:spPr>
-          <a:xfrm>
-            <a:off x="502920" y="2514600"/>
-            <a:ext cx="457200" cy="457200"/>
-          </a:xfrm>
-          <a:prstGeom prst="ellipse">
-            <a:avLst/>
-          </a:prstGeom>
-          <a:solidFill>
-            <a:srgbClr val="EEA02B"/>
-          </a:solidFill>
-          <a:ln w="12700">
-            <a:solidFill>
-              <a:srgbClr val="EEA02B"/>
-            </a:solidFill>
-            <a:prstDash val="solid"/>
-          </a:ln>
-        </p:spPr>
-      </p:sp>
-      <p:sp>
-        <p:nvSpPr>
-          <p:cNvPr id="10" name="Text 8"/>
-          <p:cNvSpPr/>
-          <p:nvPr/>
-        </p:nvSpPr>
-        <p:spPr>
-          <a:xfrm>
-            <a:off x="502920" y="2532888"/>
-            <a:ext cx="457200" cy="457200"/>
-          </a:xfrm>
-          <a:prstGeom prst="rect">
-            <a:avLst/>
-          </a:prstGeom>
-          <a:noFill/>
-          <a:ln/>
-        </p:spPr>
-        <p:txBody>
-          <a:bodyPr wrap="square" rtlCol="0" anchor="ctr"/>
-          <a:lstStyle/>
-          <a:p>
-            <a:pPr algn="ctr" indent="0" marL="0">
-              <a:buNone/>
-            </a:pPr>
-            <a:r>
-              <a:rPr lang="en-US" sz="1600" b="1" dirty="0">
-                <a:solidFill>
-                  <a:srgbClr val="0B2545"/>
-                </a:solidFill>
-                <a:latin typeface="Georgia" pitchFamily="34" charset="0"/>
-                <a:ea typeface="Georgia" pitchFamily="34" charset="-122"/>
-                <a:cs typeface="Georgia" pitchFamily="34" charset="-120"/>
-              </a:rPr>
-              <a:t>2</a:t>
-            </a:r>
-            <a:endParaRPr lang="en-US" sz="1600" dirty="0"/>
-          </a:p>
-        </p:txBody>
-      </p:sp>
-      <p:sp>
-        <p:nvSpPr>
-          <p:cNvPr id="11" name="Text 9"/>
-          <p:cNvSpPr/>
-          <p:nvPr/>
-        </p:nvSpPr>
-        <p:spPr>
-          <a:xfrm>
-            <a:off x="1143000" y="2468880"/>
-            <a:ext cx="10972800" cy="411480"/>
-          </a:xfrm>
-          <a:prstGeom prst="rect">
-            <a:avLst/>
-          </a:prstGeom>
-          <a:noFill/>
-          <a:ln/>
-        </p:spPr>
-        <p:txBody>
-          <a:bodyPr wrap="square" rtlCol="0" anchor="ctr"/>
-          <a:lstStyle/>
-          <a:p>
-            <a:pPr indent="0" marL="0">
-              <a:buNone/>
-            </a:pPr>
-            <a:r>
-              <a:rPr lang="en-US" sz="1700" b="1" dirty="0">
-                <a:solidFill>
-                  <a:srgbClr val="0B2545"/>
-                </a:solidFill>
-                <a:latin typeface="Georgia" pitchFamily="34" charset="0"/>
-                <a:ea typeface="Georgia" pitchFamily="34" charset="-122"/>
-                <a:cs typeface="Georgia" pitchFamily="34" charset="-120"/>
-              </a:rPr>
-              <a:t>Pre-registered behavioral test passed</a:t>
-            </a:r>
-            <a:endParaRPr lang="en-US" sz="1700" dirty="0"/>
-          </a:p>
-        </p:txBody>
-      </p:sp>
-      <p:sp>
-        <p:nvSpPr>
-          <p:cNvPr id="12" name="Text 10"/>
-          <p:cNvSpPr/>
-          <p:nvPr/>
-        </p:nvSpPr>
-        <p:spPr>
-          <a:xfrm>
-            <a:off x="1143000" y="2880360"/>
-            <a:ext cx="10972800" cy="548640"/>
-          </a:xfrm>
-          <a:prstGeom prst="rect">
-            <a:avLst/>
-          </a:prstGeom>
-          <a:noFill/>
-          <a:ln/>
-        </p:spPr>
-        <p:txBody>
-          <a:bodyPr wrap="square" rtlCol="0" anchor="ctr"/>
-          <a:lstStyle/>
-          <a:p>
-            <a:pPr indent="0" marL="0">
-              <a:buNone/>
-            </a:pPr>
-            <a:r>
-              <a:rPr lang="en-US" sz="1400" dirty="0">
-                <a:solidFill>
-                  <a:srgbClr val="1A1A1A"/>
-                </a:solidFill>
-                <a:latin typeface="Calibri" pitchFamily="34" charset="0"/>
-                <a:ea typeface="Calibri" pitchFamily="34" charset="-122"/>
-                <a:cs typeface="Calibri" pitchFamily="34" charset="-120"/>
-              </a:rPr>
-              <a:t>Trailing-team overreaction is real on the held-out season (p &lt; 0.0001).</a:t>
-            </a:r>
-            <a:endParaRPr lang="en-US" sz="1400" dirty="0"/>
-          </a:p>
-        </p:txBody>
-      </p:sp>
-      <p:sp>
-        <p:nvSpPr>
-          <p:cNvPr id="13" name="Shape 11"/>
-          <p:cNvSpPr/>
-          <p:nvPr/>
-        </p:nvSpPr>
-        <p:spPr>
-          <a:xfrm>
-            <a:off x="502920" y="3474720"/>
-            <a:ext cx="457200" cy="457200"/>
-          </a:xfrm>
-          <a:prstGeom prst="ellipse">
-            <a:avLst/>
-          </a:prstGeom>
-          <a:solidFill>
-            <a:srgbClr val="EEA02B"/>
-          </a:solidFill>
-          <a:ln w="12700">
-            <a:solidFill>
-              <a:srgbClr val="EEA02B"/>
-            </a:solidFill>
-            <a:prstDash val="solid"/>
-          </a:ln>
-        </p:spPr>
-      </p:sp>
-      <p:sp>
-        <p:nvSpPr>
-          <p:cNvPr id="14" name="Text 12"/>
-          <p:cNvSpPr/>
-          <p:nvPr/>
-        </p:nvSpPr>
-        <p:spPr>
-          <a:xfrm>
-            <a:off x="502920" y="3493008"/>
-            <a:ext cx="457200" cy="457200"/>
-          </a:xfrm>
-          <a:prstGeom prst="rect">
-            <a:avLst/>
-          </a:prstGeom>
-          <a:noFill/>
-          <a:ln/>
-        </p:spPr>
-        <p:txBody>
-          <a:bodyPr wrap="square" rtlCol="0" anchor="ctr"/>
-          <a:lstStyle/>
-          <a:p>
-            <a:pPr algn="ctr" indent="0" marL="0">
-              <a:buNone/>
-            </a:pPr>
-            <a:r>
-              <a:rPr lang="en-US" sz="1600" b="1" dirty="0">
-                <a:solidFill>
-                  <a:srgbClr val="0B2545"/>
-                </a:solidFill>
-                <a:latin typeface="Georgia" pitchFamily="34" charset="0"/>
-                <a:ea typeface="Georgia" pitchFamily="34" charset="-122"/>
-                <a:cs typeface="Georgia" pitchFamily="34" charset="-120"/>
-              </a:rPr>
-              <a:t>3</a:t>
-            </a:r>
-            <a:endParaRPr lang="en-US" sz="1600" dirty="0"/>
-          </a:p>
-        </p:txBody>
-      </p:sp>
-      <p:sp>
-        <p:nvSpPr>
-          <p:cNvPr id="15" name="Text 13"/>
-          <p:cNvSpPr/>
-          <p:nvPr/>
-        </p:nvSpPr>
-        <p:spPr>
-          <a:xfrm>
-            <a:off x="1143000" y="3429000"/>
-            <a:ext cx="10972800" cy="411480"/>
-          </a:xfrm>
-          <a:prstGeom prst="rect">
-            <a:avLst/>
-          </a:prstGeom>
-          <a:noFill/>
-          <a:ln/>
-        </p:spPr>
-        <p:txBody>
-          <a:bodyPr wrap="square" rtlCol="0" anchor="ctr"/>
-          <a:lstStyle/>
-          <a:p>
-            <a:pPr indent="0" marL="0">
-              <a:buNone/>
-            </a:pPr>
-            <a:r>
-              <a:rPr lang="en-US" sz="1700" b="1" dirty="0">
-                <a:solidFill>
-                  <a:srgbClr val="0B2545"/>
-                </a:solidFill>
-                <a:latin typeface="Georgia" pitchFamily="34" charset="0"/>
-                <a:ea typeface="Georgia" pitchFamily="34" charset="-122"/>
-                <a:cs typeface="Georgia" pitchFamily="34" charset="-120"/>
-              </a:rPr>
-              <a:t>Full pipeline runs end-to-end on real data</a:t>
-            </a:r>
-            <a:endParaRPr lang="en-US" sz="1700" dirty="0"/>
-          </a:p>
-        </p:txBody>
-      </p:sp>
-      <p:sp>
-        <p:nvSpPr>
-          <p:cNvPr id="16" name="Text 14"/>
-          <p:cNvSpPr/>
-          <p:nvPr/>
-        </p:nvSpPr>
-        <p:spPr>
-          <a:xfrm>
-            <a:off x="1143000" y="3840480"/>
-            <a:ext cx="10972800" cy="548640"/>
-          </a:xfrm>
-          <a:prstGeom prst="rect">
-            <a:avLst/>
-          </a:prstGeom>
-          <a:noFill/>
-          <a:ln/>
-        </p:spPr>
-        <p:txBody>
-          <a:bodyPr wrap="square" rtlCol="0" anchor="ctr"/>
-          <a:lstStyle/>
-          <a:p>
-            <a:pPr indent="0" marL="0">
-              <a:buNone/>
-            </a:pPr>
-            <a:r>
-              <a:rPr lang="en-US" sz="1400" dirty="0">
-                <a:solidFill>
-                  <a:srgbClr val="1A1A1A"/>
-                </a:solidFill>
-                <a:latin typeface="Calibri" pitchFamily="34" charset="0"/>
-                <a:ea typeface="Calibri" pitchFamily="34" charset="-122"/>
-                <a:cs typeface="Calibri" pitchFamily="34" charset="-120"/>
-              </a:rPr>
-              <a:t>model → de-vig → edge → Kelly → settle → bootstrap. 5/5 honesty gates.</a:t>
-            </a:r>
-            <a:endParaRPr lang="en-US" sz="1400" dirty="0"/>
-          </a:p>
-        </p:txBody>
-      </p:sp>
-      <p:sp>
-        <p:nvSpPr>
-          <p:cNvPr id="17" name="Shape 15"/>
-          <p:cNvSpPr/>
-          <p:nvPr/>
-        </p:nvSpPr>
-        <p:spPr>
-          <a:xfrm>
-            <a:off x="502920" y="4434840"/>
-            <a:ext cx="457200" cy="457200"/>
-          </a:xfrm>
-          <a:prstGeom prst="ellipse">
-            <a:avLst/>
-          </a:prstGeom>
-          <a:solidFill>
-            <a:srgbClr val="EEA02B"/>
-          </a:solidFill>
-          <a:ln w="12700">
-            <a:solidFill>
-              <a:srgbClr val="EEA02B"/>
-            </a:solidFill>
-            <a:prstDash val="solid"/>
-          </a:ln>
-        </p:spPr>
-      </p:sp>
-      <p:sp>
-        <p:nvSpPr>
-          <p:cNvPr id="18" name="Text 16"/>
-          <p:cNvSpPr/>
-          <p:nvPr/>
-        </p:nvSpPr>
-        <p:spPr>
-          <a:xfrm>
-            <a:off x="502920" y="4453128"/>
-            <a:ext cx="457200" cy="457200"/>
-          </a:xfrm>
-          <a:prstGeom prst="rect">
-            <a:avLst/>
-          </a:prstGeom>
-          <a:noFill/>
-          <a:ln/>
-        </p:spPr>
-        <p:txBody>
-          <a:bodyPr wrap="square" rtlCol="0" anchor="ctr"/>
-          <a:lstStyle/>
-          <a:p>
-            <a:pPr algn="ctr" indent="0" marL="0">
-              <a:buNone/>
-            </a:pPr>
-            <a:r>
-              <a:rPr lang="en-US" sz="1600" b="1" dirty="0">
-                <a:solidFill>
-                  <a:srgbClr val="0B2545"/>
-                </a:solidFill>
-                <a:latin typeface="Georgia" pitchFamily="34" charset="0"/>
-                <a:ea typeface="Georgia" pitchFamily="34" charset="-122"/>
-                <a:cs typeface="Georgia" pitchFamily="34" charset="-120"/>
-              </a:rPr>
-              <a:t>4</a:t>
-            </a:r>
-            <a:endParaRPr lang="en-US" sz="1600" dirty="0"/>
-          </a:p>
-        </p:txBody>
-      </p:sp>
-      <p:sp>
-        <p:nvSpPr>
-          <p:cNvPr id="19" name="Text 17"/>
-          <p:cNvSpPr/>
-          <p:nvPr/>
-        </p:nvSpPr>
-        <p:spPr>
-          <a:xfrm>
-            <a:off x="1143000" y="4389120"/>
-            <a:ext cx="10972800" cy="411480"/>
-          </a:xfrm>
-          <a:prstGeom prst="rect">
-            <a:avLst/>
-          </a:prstGeom>
-          <a:noFill/>
-          <a:ln/>
-        </p:spPr>
-        <p:txBody>
-          <a:bodyPr wrap="square" rtlCol="0" anchor="ctr"/>
-          <a:lstStyle/>
-          <a:p>
-            <a:pPr indent="0" marL="0">
-              <a:buNone/>
-            </a:pPr>
-            <a:r>
-              <a:rPr lang="en-US" sz="1700" b="1" dirty="0">
-                <a:solidFill>
-                  <a:srgbClr val="0B2545"/>
-                </a:solidFill>
-                <a:latin typeface="Georgia" pitchFamily="34" charset="0"/>
-                <a:ea typeface="Georgia" pitchFamily="34" charset="-122"/>
-                <a:cs typeface="Georgia" pitchFamily="34" charset="-120"/>
-              </a:rPr>
-              <a:t>The honest backtest answer</a:t>
-            </a:r>
-            <a:endParaRPr lang="en-US" sz="1700" dirty="0"/>
-          </a:p>
-        </p:txBody>
-      </p:sp>
-      <p:sp>
-        <p:nvSpPr>
-          <p:cNvPr id="20" name="Text 18"/>
-          <p:cNvSpPr/>
-          <p:nvPr/>
-        </p:nvSpPr>
-        <p:spPr>
-          <a:xfrm>
-            <a:off x="1143000" y="4800600"/>
-            <a:ext cx="10972800" cy="548640"/>
-          </a:xfrm>
-          <a:prstGeom prst="rect">
-            <a:avLst/>
-          </a:prstGeom>
-          <a:noFill/>
-          <a:ln/>
-        </p:spPr>
-        <p:txBody>
-          <a:bodyPr wrap="square" rtlCol="0" anchor="ctr"/>
-          <a:lstStyle/>
-          <a:p>
-            <a:pPr indent="0" marL="0">
-              <a:buNone/>
-            </a:pPr>
-            <a:r>
-              <a:rPr lang="en-US" sz="1400" dirty="0">
-                <a:solidFill>
-                  <a:srgbClr val="1A1A1A"/>
-                </a:solidFill>
-                <a:latin typeface="Calibri" pitchFamily="34" charset="0"/>
-                <a:ea typeface="Calibri" pitchFamily="34" charset="-122"/>
-                <a:cs typeface="Calibri" pitchFamily="34" charset="-120"/>
-              </a:rPr>
-              <a:t>Pipeline ready · scale gates the trustworthy P&amp;L (n=1 lesson made tangible).</a:t>
-            </a:r>
-            <a:endParaRPr lang="en-US" sz="1400" dirty="0"/>
-          </a:p>
-        </p:txBody>
-      </p:sp>
-      <p:sp>
-        <p:nvSpPr>
-          <p:cNvPr id="21" name="Shape 19"/>
-          <p:cNvSpPr/>
-          <p:nvPr/>
-        </p:nvSpPr>
-        <p:spPr>
-          <a:xfrm>
-            <a:off x="502920" y="5394960"/>
-            <a:ext cx="457200" cy="457200"/>
-          </a:xfrm>
-          <a:prstGeom prst="ellipse">
-            <a:avLst/>
-          </a:prstGeom>
-          <a:solidFill>
-            <a:srgbClr val="EEA02B"/>
-          </a:solidFill>
-          <a:ln w="12700">
-            <a:solidFill>
-              <a:srgbClr val="EEA02B"/>
-            </a:solidFill>
-            <a:prstDash val="solid"/>
-          </a:ln>
-        </p:spPr>
-      </p:sp>
-      <p:sp>
-        <p:nvSpPr>
-          <p:cNvPr id="22" name="Text 20"/>
-          <p:cNvSpPr/>
-          <p:nvPr/>
-        </p:nvSpPr>
-        <p:spPr>
-          <a:xfrm>
-            <a:off x="502920" y="5413248"/>
-            <a:ext cx="457200" cy="457200"/>
-          </a:xfrm>
-          <a:prstGeom prst="rect">
-            <a:avLst/>
-          </a:prstGeom>
-          <a:noFill/>
-          <a:ln/>
-        </p:spPr>
-        <p:txBody>
-          <a:bodyPr wrap="square" rtlCol="0" anchor="ctr"/>
-          <a:lstStyle/>
-          <a:p>
-            <a:pPr algn="ctr" indent="0" marL="0">
-              <a:buNone/>
-            </a:pPr>
-            <a:r>
-              <a:rPr lang="en-US" sz="1600" b="1" dirty="0">
-                <a:solidFill>
-                  <a:srgbClr val="0B2545"/>
-                </a:solidFill>
-                <a:latin typeface="Georgia" pitchFamily="34" charset="0"/>
-                <a:ea typeface="Georgia" pitchFamily="34" charset="-122"/>
-                <a:cs typeface="Georgia" pitchFamily="34" charset="-120"/>
-              </a:rPr>
-              <a:t>5</a:t>
-            </a:r>
-            <a:endParaRPr lang="en-US" sz="1600" dirty="0"/>
-          </a:p>
-        </p:txBody>
-      </p:sp>
-      <p:sp>
-        <p:nvSpPr>
-          <p:cNvPr id="23" name="Text 21"/>
-          <p:cNvSpPr/>
-          <p:nvPr/>
-        </p:nvSpPr>
-        <p:spPr>
-          <a:xfrm>
-            <a:off x="1143000" y="5349240"/>
-            <a:ext cx="10972800" cy="411480"/>
-          </a:xfrm>
-          <a:prstGeom prst="rect">
-            <a:avLst/>
-          </a:prstGeom>
-          <a:noFill/>
-          <a:ln/>
-        </p:spPr>
-        <p:txBody>
-          <a:bodyPr wrap="square" rtlCol="0" anchor="ctr"/>
-          <a:lstStyle/>
-          <a:p>
-            <a:pPr indent="0" marL="0">
-              <a:buNone/>
-            </a:pPr>
-            <a:r>
-              <a:rPr lang="en-US" sz="1700" b="1" dirty="0">
-                <a:solidFill>
-                  <a:srgbClr val="0B2545"/>
-                </a:solidFill>
-                <a:latin typeface="Georgia" pitchFamily="34" charset="0"/>
-                <a:ea typeface="Georgia" pitchFamily="34" charset="-122"/>
-                <a:cs typeface="Georgia" pitchFamily="34" charset="-120"/>
-              </a:rPr>
-              <a:t>Halawi-tied story</a:t>
-            </a:r>
-            <a:endParaRPr lang="en-US" sz="1700" dirty="0"/>
-          </a:p>
-        </p:txBody>
-      </p:sp>
-      <p:sp>
-        <p:nvSpPr>
-          <p:cNvPr id="24" name="Text 22"/>
-          <p:cNvSpPr/>
-          <p:nvPr/>
-        </p:nvSpPr>
-        <p:spPr>
-          <a:xfrm>
-            <a:off x="1143000" y="5760720"/>
-            <a:ext cx="10972800" cy="548640"/>
-          </a:xfrm>
-          <a:prstGeom prst="rect">
-            <a:avLst/>
-          </a:prstGeom>
-          <a:noFill/>
-          <a:ln/>
-        </p:spPr>
-        <p:txBody>
-          <a:bodyPr wrap="square" rtlCol="0" anchor="ctr"/>
-          <a:lstStyle/>
-          <a:p>
-            <a:pPr indent="0" marL="0">
-              <a:buNone/>
-            </a:pPr>
-            <a:r>
-              <a:rPr lang="en-US" sz="1400" dirty="0">
-                <a:solidFill>
-                  <a:srgbClr val="1A1A1A"/>
-                </a:solidFill>
-                <a:latin typeface="Calibri" pitchFamily="34" charset="0"/>
-                <a:ea typeface="Calibri" pitchFamily="34" charset="-122"/>
-                <a:cs typeface="Calibri" pitchFamily="34" charset="-120"/>
-              </a:rPr>
-              <a:t>Model and crowd are complementary error sources — not competing oracles.</a:t>
-            </a:r>
-            <a:endParaRPr lang="en-US" sz="1400" dirty="0"/>
-          </a:p>
-        </p:txBody>
-      </p:sp>
-      <p:sp>
-        <p:nvSpPr>
-          <p:cNvPr id="25" name="Text 23"/>
-          <p:cNvSpPr/>
-          <p:nvPr/>
-        </p:nvSpPr>
-        <p:spPr>
-          <a:xfrm>
-            <a:off x="502920" y="6309360"/>
-            <a:ext cx="11247120" cy="411480"/>
-          </a:xfrm>
-          <a:prstGeom prst="rect">
-            <a:avLst/>
-          </a:prstGeom>
-          <a:noFill/>
-          <a:ln/>
-        </p:spPr>
-        <p:txBody>
-          <a:bodyPr wrap="square" rtlCol="0" anchor="ctr"/>
-          <a:lstStyle/>
-          <a:p>
-            <a:pPr algn="ctr" indent="0" marL="0">
-              <a:buNone/>
-            </a:pPr>
-            <a:r>
-              <a:rPr lang="en-US" sz="2000" b="1" i="1" dirty="0">
-                <a:solidFill>
-                  <a:srgbClr val="1C7293"/>
-                </a:solidFill>
-                <a:latin typeface="Georgia" pitchFamily="34" charset="0"/>
-                <a:ea typeface="Georgia" pitchFamily="34" charset="-122"/>
-                <a:cs typeface="Georgia" pitchFamily="34" charset="-120"/>
-              </a:rPr>
-              <a:t>Thank you. Questions?</a:t>
-            </a:r>
-            <a:endParaRPr lang="en-US" sz="2000" dirty="0"/>
-          </a:p>
-        </p:txBody>
-      </p:sp>
-      <p:sp>
-        <p:nvSpPr>
-          <p:cNvPr id="26" name="Text 24"/>
-          <p:cNvSpPr/>
-          <p:nvPr/>
-        </p:nvSpPr>
-        <p:spPr>
-          <a:xfrm>
-            <a:off x="502920" y="6492240"/>
-            <a:ext cx="7315200" cy="274320"/>
-          </a:xfrm>
-          <a:prstGeom prst="rect">
-            <a:avLst/>
-          </a:prstGeom>
-          <a:noFill/>
-          <a:ln/>
-        </p:spPr>
-        <p:txBody>
-          <a:bodyPr wrap="square" rtlCol="0" anchor="ctr"/>
-          <a:lstStyle/>
-          <a:p>
-            <a:pPr indent="0" marL="0">
-              <a:buNone/>
-            </a:pPr>
-            <a:r>
-              <a:rPr lang="en-US" sz="1000" dirty="0">
-                <a:solidFill>
-                  <a:srgbClr val="8DA9C4"/>
-                </a:solidFill>
-                <a:latin typeface="Calibri" pitchFamily="34" charset="0"/>
-                <a:ea typeface="Calibri" pitchFamily="34" charset="-122"/>
-                <a:cs typeface="Calibri" pitchFamily="34" charset="-120"/>
-              </a:rPr>
               <a:t>STATS 211 · NBA Mispricing · Sit &amp; Manathattai</a:t>
             </a:r>
             <a:endParaRPr lang="en-US" sz="1000" dirty="0"/>
@@ -5042,7 +5664,7 @@
       </p:sp>
       <p:sp>
         <p:nvSpPr>
-          <p:cNvPr id="27" name="Text 25"/>
+          <p:cNvPr id="30" name="Text 27"/>
           <p:cNvSpPr/>
           <p:nvPr/>
         </p:nvSpPr>
@@ -8701,7 +9323,7 @@
                 <a:ea typeface="Calibri" pitchFamily="34" charset="-122"/>
                 <a:cs typeface="Calibri" pitchFamily="34" charset="-120"/>
               </a:rPr>
-              <a:t>Why simple is right for a 3-page paper:</a:t>
+              <a:t>Why we kept it simple:</a:t>
             </a:r>
             <a:endParaRPr lang="en-US" sz="1400" dirty="0"/>
           </a:p>
@@ -8740,7 +9362,7 @@
                 <a:ea typeface="Calibri" pitchFamily="34" charset="-122"/>
                 <a:cs typeface="Calibri" pitchFamily="34" charset="-120"/>
               </a:rPr>
-              <a:t>Every choice defensible. No overfitting story. Brier-comparable to published NBA in-game WP models (Bashuk; Lopez &amp; Matthews).</a:t>
+              <a:t>Every choice defensible. No overfitting. Brier-comparable to published NBA in-game WP models (Bashuk; Lopez &amp; Matthews).</a:t>
             </a:r>
             <a:endParaRPr lang="en-US" sz="1500" dirty="0"/>
           </a:p>

</xml_diff>

<commit_message>
Slides: simplify research question + Game 6 pilot + drop H1/H4 jargon
Research question: ONE top-level question + two sub-questions
  Q: 'Can we use a calibrated WP model to detect mispricing and profit
      from it in NBA in-play markets?'
  Sub-Q1: Is the bias detectable?  -> overreaction-test slide
  Sub-Q2: Can we make money?       -> pilot + verdict slides

Game 6 pilot (NEW): per-game model ROI bar chart, Game 6 highlighted
  · Game 6 alone: +12% on Kalshi 1H (smallest of the 5)
  · 5-game pool: +95% (artifact -- stale-mid + n=5)
  · Replaces the standalone liquidity-only slide

H1/H4 -> plain English:
  · H1 -> 'Comeback FG (trail 10-15)'
  · H4 -> 'Salience 3PT (trail >=10)'
  · v5_shifts.png chart labels updated
  · Removed H1/H4 from research question, overreaction test, Halawi tie-back,
    verdict, workflow diagram, results table, and money-question sections
  · 'pre-registered' kept (it's the methodological badge)

Speaker script renumbered to match new flow.
</commit_message>
<xml_diff>
--- a/slides/final_deck.pptx
+++ b/slides/final_deck.pptx
@@ -2777,7 +2777,7 @@
                 <a:ea typeface="Georgia" pitchFamily="34" charset="-122"/>
                 <a:cs typeface="Georgia" pitchFamily="34" charset="-120"/>
               </a:rPr>
-              <a:t>Liquidity × sample size are everything</a:t>
+              <a:t>Game 6 pilot · OKC @ SAS, 2026-05-28  (FINAL SAS 118–91)</a:t>
             </a:r>
             <a:endParaRPr lang="en-US" sz="2800" dirty="0"/>
           </a:p>
@@ -2816,7 +2816,7 @@
                 <a:ea typeface="Calibri" pitchFamily="34" charset="-122"/>
                 <a:cs typeface="Calibri" pitchFamily="34" charset="-120"/>
               </a:rPr>
-              <a:t>Same model family · two opposite results</a:t>
+              <a:t>61 in-1H ticks on Kalshi · the 5-game pool tells the rest of the story</a:t>
             </a:r>
             <a:endParaRPr lang="en-US" sz="1400" dirty="0"/>
           </a:p>
@@ -2847,7 +2847,7 @@
       </p:sp>
       <p:pic>
         <p:nvPicPr>
-          <p:cNvPr id="5" name="Image 0" descr="slides/figures/liquidity_sample.png">    </p:cNvPr>
+          <p:cNvPr id="5" name="Image 0" descr="slides/figures/game6_pilot.png">    </p:cNvPr>
           <p:cNvPicPr>
             <a:picLocks noChangeAspect="1"/>
           </p:cNvPicPr>
@@ -2861,8 +2861,8 @@
         </p:blipFill>
         <p:spPr>
           <a:xfrm>
-            <a:off x="2468880" y="1417320"/>
-            <a:ext cx="7315200" cy="4572000"/>
+            <a:off x="1554480" y="1371600"/>
+            <a:ext cx="9052560" cy="4206240"/>
           </a:xfrm>
           <a:prstGeom prst="rect">
             <a:avLst/>
@@ -2877,12 +2877,12 @@
         </p:nvSpPr>
         <p:spPr>
           <a:xfrm>
-            <a:off x="502920" y="5943600"/>
-            <a:ext cx="11247120" cy="640080"/>
+            <a:off x="502920" y="5669280"/>
+            <a:ext cx="11247120" cy="914400"/>
           </a:xfrm>
           <a:prstGeom prst="roundRect">
             <a:avLst>
-              <a:gd name="adj" fmla="val 11429"/>
+              <a:gd name="adj" fmla="val 8000"/>
             </a:avLst>
           </a:prstGeom>
           <a:solidFill>
@@ -2904,60 +2904,88 @@
         </p:nvSpPr>
         <p:spPr>
           <a:xfrm>
-            <a:off x="777240" y="5989320"/>
-            <a:ext cx="10698480" cy="548640"/>
-          </a:xfrm>
-          <a:prstGeom prst="rect">
-            <a:avLst/>
-          </a:prstGeom>
-          <a:noFill/>
-          <a:ln/>
-        </p:spPr>
-        <p:txBody>
-          <a:bodyPr wrap="square" rtlCol="0" anchor="ctr"/>
-          <a:lstStyle/>
-          <a:p>
-            <a:pPr algn="ctr" indent="0" marL="0">
-              <a:buNone/>
-            </a:pPr>
-            <a:r>
-              <a:rPr lang="en-US" sz="1300" dirty="0">
-                <a:solidFill>
-                  <a:srgbClr val="1A1A1A"/>
+            <a:off x="777240" y="5760720"/>
+            <a:ext cx="10698480" cy="777240"/>
+          </a:xfrm>
+          <a:prstGeom prst="rect">
+            <a:avLst/>
+          </a:prstGeom>
+          <a:noFill/>
+          <a:ln/>
+        </p:spPr>
+        <p:txBody>
+          <a:bodyPr wrap="square" rtlCol="0" anchor="ctr"/>
+          <a:lstStyle/>
+          <a:p>
+            <a:pPr indent="0" marL="0">
+              <a:buNone/>
+            </a:pPr>
+            <a:r>
+              <a:rPr lang="en-US" sz="1300" b="1" dirty="0">
+                <a:solidFill>
+                  <a:srgbClr val="0B2545"/>
                 </a:solidFill>
                 <a:latin typeface="Calibri" pitchFamily="34" charset="0"/>
                 <a:ea typeface="Calibri" pitchFamily="34" charset="-122"/>
                 <a:cs typeface="Calibri" pitchFamily="34" charset="-120"/>
               </a:rPr>
-              <a:t>The +100% against Kalshi is </a:t>
-            </a:r>
-            <a:pPr algn="ctr" indent="0" marL="0">
-              <a:buNone/>
-            </a:pPr>
-            <a:r>
-              <a:rPr lang="en-US" sz="1300" b="1" dirty="0">
-                <a:solidFill>
-                  <a:srgbClr val="0B2545"/>
+              <a:t>Game 6 alone: </a:t>
+            </a:r>
+            <a:pPr indent="0" marL="0">
+              <a:buNone/>
+            </a:pPr>
+            <a:r>
+              <a:rPr lang="en-US" sz="1300" dirty="0">
+                <a:solidFill>
+                  <a:srgbClr val="1A1A1A"/>
                 </a:solidFill>
                 <a:latin typeface="Calibri" pitchFamily="34" charset="0"/>
                 <a:ea typeface="Calibri" pitchFamily="34" charset="-122"/>
                 <a:cs typeface="Calibri" pitchFamily="34" charset="-120"/>
               </a:rPr>
-              <a:t>stale mid-prices + n=4 + no slippage</a:t>
-            </a:r>
-            <a:pPr algn="ctr" indent="0" marL="0">
-              <a:buNone/>
-            </a:pPr>
-            <a:r>
-              <a:rPr lang="en-US" sz="1300" dirty="0">
-                <a:solidFill>
-                  <a:srgbClr val="1A1A1A"/>
+              <a:t>model +12% on Kalshi 1H (smallest of the 5). </a:t>
+            </a:r>
+            <a:pPr indent="0" marL="0">
+              <a:buNone/>
+            </a:pPr>
+            <a:r>
+              <a:rPr lang="en-US" sz="1300" b="1" dirty="0">
+                <a:solidFill>
+                  <a:srgbClr val="EEA02B"/>
                 </a:solidFill>
                 <a:latin typeface="Calibri" pitchFamily="34" charset="0"/>
                 <a:ea typeface="Calibri" pitchFamily="34" charset="-122"/>
                 <a:cs typeface="Calibri" pitchFamily="34" charset="-120"/>
               </a:rPr>
-              <a:t> — exactly the trap CLAUDE.md warns about. Real liquid markets are tight.</a:t>
+              <a:t>Pool of 5: +95%. </a:t>
+            </a:r>
+            <a:pPr indent="0" marL="0">
+              <a:buNone/>
+            </a:pPr>
+            <a:r>
+              <a:rPr lang="en-US" sz="1300" dirty="0">
+                <a:solidFill>
+                  <a:srgbClr val="1A1A1A"/>
+                </a:solidFill>
+                <a:latin typeface="Calibri" pitchFamily="34" charset="0"/>
+                <a:ea typeface="Calibri" pitchFamily="34" charset="-122"/>
+                <a:cs typeface="Calibri" pitchFamily="34" charset="-120"/>
+              </a:rPr>
+              <a:t>But Kalshi 1H prices were thin and stale, so the model 'beats' a price that isn't moving — </a:t>
+            </a:r>
+            <a:pPr indent="0" marL="0">
+              <a:buNone/>
+            </a:pPr>
+            <a:r>
+              <a:rPr lang="en-US" sz="1300" i="1" dirty="0">
+                <a:solidFill>
+                  <a:srgbClr val="13315C"/>
+                </a:solidFill>
+                <a:latin typeface="Calibri" pitchFamily="34" charset="0"/>
+                <a:ea typeface="Calibri" pitchFamily="34" charset="-122"/>
+                <a:cs typeface="Calibri" pitchFamily="34" charset="-120"/>
+              </a:rPr>
+              <a:t>stale-mid + n=5 + mid quotes = artifact, not edge.</a:t>
             </a:r>
             <a:endParaRPr lang="en-US" sz="1300" dirty="0"/>
           </a:p>
@@ -3512,7 +3540,7 @@
                 <a:ea typeface="Calibri" pitchFamily="34" charset="-122"/>
                 <a:cs typeface="Calibri" pitchFamily="34" charset="-120"/>
               </a:rPr>
-              <a:t>The model's job isn't to BEAT the market everywhere — it's to COMPLEMENT it in the specific situations where the crowd's bias is strongest (H1 / H4).</a:t>
+              <a:t>The model's job isn't to BEAT the market everywhere — it's to COMPLEMENT it in the specific situations (comeback FG, salience 3PT) where the crowd's bias is strongest.</a:t>
             </a:r>
             <a:endParaRPr lang="en-US" sz="1500" dirty="0"/>
           </a:p>
@@ -4623,7 +4651,7 @@
                             <a:srgbClr val="0B2545"/>
                           </a:solidFill>
                         </a:rPr>
-                        <a:t>H1 trail 10–15, FG</a:t>
+                        <a:t>Comeback FG (trail 10–15)</a:t>
                       </a:r>
                       <a:endParaRPr lang="en-US" sz="1200" dirty="0"/>
                     </a:p>
@@ -4799,7 +4827,7 @@
                             <a:srgbClr val="0B2545"/>
                           </a:solidFill>
                         </a:rPr>
-                        <a:t>H4 trail ≥10, 3PT</a:t>
+                        <a:t>Salience 3PT (trail ≥10)</a:t>
                       </a:r>
                       <a:endParaRPr lang="en-US" sz="1200" dirty="0"/>
                     </a:p>
@@ -5411,7 +5439,7 @@
                 <a:ea typeface="Calibri" pitchFamily="34" charset="-122"/>
                 <a:cs typeface="Calibri" pitchFamily="34" charset="-120"/>
               </a:rPr>
-              <a:t>V5 H1/H4 pre-reg passed on the held-out season. The overreaction is real.</a:t>
+              <a:t>Both pre-registered tests passed on the held-out season. The overreaction is real.</a:t>
             </a:r>
             <a:endParaRPr lang="en-US" sz="1200" dirty="0"/>
           </a:p>
@@ -6297,7 +6325,7 @@
                 <a:ea typeface="Calibri" pitchFamily="34" charset="-122"/>
                 <a:cs typeface="Calibri" pitchFamily="34" charset="-120"/>
               </a:rPr>
-              <a:t>Pre-registered before any test-set data was touched</a:t>
+              <a:t>One question, two sub-questions</a:t>
             </a:r>
             <a:endParaRPr lang="en-US" sz="1400" dirty="0"/>
           </a:p>
@@ -6334,7 +6362,7 @@
         </p:nvSpPr>
         <p:spPr>
           <a:xfrm>
-            <a:off x="502920" y="1508760"/>
+            <a:off x="502920" y="1463040"/>
             <a:ext cx="11247120" cy="1691640"/>
           </a:xfrm>
           <a:prstGeom prst="roundRect">
@@ -6345,7 +6373,7 @@
           <a:solidFill>
             <a:srgbClr val="F6F6F2"/>
           </a:solidFill>
-          <a:ln w="19050">
+          <a:ln w="22860">
             <a:solidFill>
               <a:srgbClr val="1C7293"/>
             </a:solidFill>
@@ -6362,7 +6390,7 @@
         <p:spPr>
           <a:xfrm>
             <a:off x="777240" y="1691640"/>
-            <a:ext cx="10698480" cy="1371600"/>
+            <a:ext cx="10698480" cy="1280160"/>
           </a:xfrm>
           <a:prstGeom prst="rect">
             <a:avLst/>
@@ -6378,7 +6406,7 @@
               <a:buNone/>
             </a:pPr>
             <a:r>
-              <a:rPr lang="en-US" sz="2000" i="1" dirty="0">
+              <a:rPr lang="en-US" sz="2200" i="1" dirty="0">
                 <a:solidFill>
                   <a:srgbClr val="0B2545"/>
                 </a:solidFill>
@@ -6386,9 +6414,65 @@
                 <a:ea typeface="Georgia" pitchFamily="34" charset="-122"/>
                 <a:cs typeface="Georgia" pitchFamily="34" charset="-120"/>
               </a:rPr>
-              <a:t>Can a calibrated in-game NBA win-probability model systematically identify live-market mispricings driven by crowd overreaction — specifically in trailing-team scoring events?</a:t>
-            </a:r>
-            <a:endParaRPr lang="en-US" sz="2000" dirty="0"/>
+              <a:t>Can we use a calibrated win-probability model to </a:t>
+            </a:r>
+            <a:pPr indent="0" marL="0">
+              <a:buNone/>
+            </a:pPr>
+            <a:r>
+              <a:rPr lang="en-US" sz="2200" b="1" i="1" dirty="0">
+                <a:solidFill>
+                  <a:srgbClr val="0B2545"/>
+                </a:solidFill>
+                <a:latin typeface="Georgia" pitchFamily="34" charset="0"/>
+                <a:ea typeface="Georgia" pitchFamily="34" charset="-122"/>
+                <a:cs typeface="Georgia" pitchFamily="34" charset="-120"/>
+              </a:rPr>
+              <a:t>detect mispricing</a:t>
+            </a:r>
+            <a:pPr indent="0" marL="0">
+              <a:buNone/>
+            </a:pPr>
+            <a:r>
+              <a:rPr lang="en-US" sz="2200" i="1" dirty="0">
+                <a:solidFill>
+                  <a:srgbClr val="0B2545"/>
+                </a:solidFill>
+                <a:latin typeface="Georgia" pitchFamily="34" charset="0"/>
+                <a:ea typeface="Georgia" pitchFamily="34" charset="-122"/>
+                <a:cs typeface="Georgia" pitchFamily="34" charset="-120"/>
+              </a:rPr>
+              <a:t> and </a:t>
+            </a:r>
+            <a:pPr indent="0" marL="0">
+              <a:buNone/>
+            </a:pPr>
+            <a:r>
+              <a:rPr lang="en-US" sz="2200" b="1" i="1" dirty="0">
+                <a:solidFill>
+                  <a:srgbClr val="EEA02B"/>
+                </a:solidFill>
+                <a:latin typeface="Georgia" pitchFamily="34" charset="0"/>
+                <a:ea typeface="Georgia" pitchFamily="34" charset="-122"/>
+                <a:cs typeface="Georgia" pitchFamily="34" charset="-120"/>
+              </a:rPr>
+              <a:t>profit from it</a:t>
+            </a:r>
+            <a:pPr indent="0" marL="0">
+              <a:buNone/>
+            </a:pPr>
+            <a:r>
+              <a:rPr lang="en-US" sz="2200" i="1" dirty="0">
+                <a:solidFill>
+                  <a:srgbClr val="0B2545"/>
+                </a:solidFill>
+                <a:latin typeface="Georgia" pitchFamily="34" charset="0"/>
+                <a:ea typeface="Georgia" pitchFamily="34" charset="-122"/>
+                <a:cs typeface="Georgia" pitchFamily="34" charset="-120"/>
+              </a:rPr>
+              <a:t> in NBA in-play markets?</a:t>
+            </a:r>
+            <a:endParaRPr lang="en-US" sz="2200" dirty="0"/>
           </a:p>
         </p:txBody>
       </p:sp>
@@ -6400,7 +6484,7 @@
         </p:nvSpPr>
         <p:spPr>
           <a:xfrm>
-            <a:off x="502920" y="3520440"/>
+            <a:off x="502920" y="3383280"/>
             <a:ext cx="11247120" cy="365760"/>
           </a:xfrm>
           <a:prstGeom prst="rect">
@@ -6413,11 +6497,11 @@
           <a:bodyPr wrap="square" rtlCol="0" anchor="ctr"/>
           <a:lstStyle/>
           <a:p>
-            <a:pPr indent="0" marL="0">
-              <a:buNone/>
-            </a:pPr>
-            <a:r>
-              <a:rPr lang="en-US" sz="1600" b="1" dirty="0">
+            <a:pPr algn="ctr" indent="0" marL="0">
+              <a:buNone/>
+            </a:pPr>
+            <a:r>
+              <a:rPr lang="en-US" sz="1400" b="1" i="1" dirty="0">
                 <a:solidFill>
                   <a:srgbClr val="13315C"/>
                 </a:solidFill>
@@ -6425,22 +6509,49 @@
                 <a:ea typeface="Calibri" pitchFamily="34" charset="-122"/>
                 <a:cs typeface="Calibri" pitchFamily="34" charset="-120"/>
               </a:rPr>
-              <a:t>Two pre-registered tests:</a:t>
-            </a:r>
-            <a:endParaRPr lang="en-US" sz="1600" dirty="0"/>
-          </a:p>
-        </p:txBody>
-      </p:sp>
-      <p:sp>
-        <p:nvSpPr>
-          <p:cNvPr id="8" name="Text 6"/>
-          <p:cNvSpPr/>
-          <p:nvPr/>
-        </p:nvSpPr>
-        <p:spPr>
-          <a:xfrm>
-            <a:off x="777240" y="3977640"/>
-            <a:ext cx="10972800" cy="640080"/>
+              <a:t>Decomposes into two sub-questions we can actually answer:</a:t>
+            </a:r>
+            <a:endParaRPr lang="en-US" sz="1400" dirty="0"/>
+          </a:p>
+        </p:txBody>
+      </p:sp>
+      <p:sp>
+        <p:nvSpPr>
+          <p:cNvPr id="8" name="Shape 6"/>
+          <p:cNvSpPr/>
+          <p:nvPr/>
+        </p:nvSpPr>
+        <p:spPr>
+          <a:xfrm>
+            <a:off x="502920" y="3840480"/>
+            <a:ext cx="5486400" cy="2377440"/>
+          </a:xfrm>
+          <a:prstGeom prst="roundRect">
+            <a:avLst>
+              <a:gd name="adj" fmla="val 3846"/>
+            </a:avLst>
+          </a:prstGeom>
+          <a:solidFill>
+            <a:srgbClr val="EEF3F8"/>
+          </a:solidFill>
+          <a:ln w="19050">
+            <a:solidFill>
+              <a:srgbClr val="0B2545"/>
+            </a:solidFill>
+            <a:prstDash val="solid"/>
+          </a:ln>
+        </p:spPr>
+      </p:sp>
+      <p:sp>
+        <p:nvSpPr>
+          <p:cNvPr id="9" name="Text 7"/>
+          <p:cNvSpPr/>
+          <p:nvPr/>
+        </p:nvSpPr>
+        <p:spPr>
+          <a:xfrm>
+            <a:off x="685800" y="3931920"/>
+            <a:ext cx="5120640" cy="320040"/>
           </a:xfrm>
           <a:prstGeom prst="rect">
             <a:avLst/>
@@ -6456,21 +6567,85 @@
               <a:buNone/>
             </a:pPr>
             <a:r>
-              <a:rPr lang="en-US" sz="1600" b="1" dirty="0">
-                <a:solidFill>
-                  <a:srgbClr val="EEA02B"/>
+              <a:rPr lang="en-US" sz="1100" b="1" dirty="0">
+                <a:solidFill>
+                  <a:srgbClr val="13315C"/>
                 </a:solidFill>
                 <a:latin typeface="Calibri" pitchFamily="34" charset="0"/>
                 <a:ea typeface="Calibri" pitchFamily="34" charset="-122"/>
                 <a:cs typeface="Calibri" pitchFamily="34" charset="-120"/>
               </a:rPr>
-              <a:t>H1 (primary)</a:t>
-            </a:r>
+              <a:t>SUB-QUESTION 1</a:t>
+            </a:r>
+            <a:endParaRPr lang="en-US" sz="1100" dirty="0"/>
+          </a:p>
+        </p:txBody>
+      </p:sp>
+      <p:sp>
+        <p:nvSpPr>
+          <p:cNvPr id="10" name="Text 8"/>
+          <p:cNvSpPr/>
+          <p:nvPr/>
+        </p:nvSpPr>
+        <p:spPr>
+          <a:xfrm>
+            <a:off x="685800" y="4206240"/>
+            <a:ext cx="5120640" cy="457200"/>
+          </a:xfrm>
+          <a:prstGeom prst="rect">
+            <a:avLst/>
+          </a:prstGeom>
+          <a:noFill/>
+          <a:ln/>
+        </p:spPr>
+        <p:txBody>
+          <a:bodyPr wrap="square" rtlCol="0" anchor="ctr"/>
+          <a:lstStyle/>
+          <a:p>
             <a:pPr indent="0" marL="0">
               <a:buNone/>
             </a:pPr>
             <a:r>
-              <a:rPr lang="en-US" sz="1600" dirty="0">
+              <a:rPr lang="en-US" sz="1900" b="1" dirty="0">
+                <a:solidFill>
+                  <a:srgbClr val="0B2545"/>
+                </a:solidFill>
+                <a:latin typeface="Georgia" pitchFamily="34" charset="0"/>
+                <a:ea typeface="Georgia" pitchFamily="34" charset="-122"/>
+                <a:cs typeface="Georgia" pitchFamily="34" charset="-120"/>
+              </a:rPr>
+              <a:t>Is the bias DETECTABLE?</a:t>
+            </a:r>
+            <a:endParaRPr lang="en-US" sz="1900" dirty="0"/>
+          </a:p>
+        </p:txBody>
+      </p:sp>
+      <p:sp>
+        <p:nvSpPr>
+          <p:cNvPr id="11" name="Text 9"/>
+          <p:cNvSpPr/>
+          <p:nvPr/>
+        </p:nvSpPr>
+        <p:spPr>
+          <a:xfrm>
+            <a:off x="685800" y="4709160"/>
+            <a:ext cx="5120640" cy="960120"/>
+          </a:xfrm>
+          <a:prstGeom prst="rect">
+            <a:avLst/>
+          </a:prstGeom>
+          <a:noFill/>
+          <a:ln/>
+        </p:spPr>
+        <p:txBody>
+          <a:bodyPr wrap="square" rtlCol="0" anchor="ctr"/>
+          <a:lstStyle/>
+          <a:p>
+            <a:pPr indent="0" marL="0">
+              <a:buNone/>
+            </a:pPr>
+            <a:r>
+              <a:rPr lang="en-US" sz="1300" dirty="0">
                 <a:solidFill>
                   <a:srgbClr val="1A1A1A"/>
                 </a:solidFill>
@@ -6478,22 +6653,22 @@
                 <a:ea typeface="Calibri" pitchFamily="34" charset="-122"/>
                 <a:cs typeface="Calibri" pitchFamily="34" charset="-120"/>
               </a:rPr>
-              <a:t> — trailing team in 10–15 pt deficit hits a made FG → market over-shifts vs structural model.</a:t>
-            </a:r>
-            <a:endParaRPr lang="en-US" sz="1600" dirty="0"/>
-          </a:p>
-        </p:txBody>
-      </p:sp>
-      <p:sp>
-        <p:nvSpPr>
-          <p:cNvPr id="9" name="Text 7"/>
-          <p:cNvSpPr/>
-          <p:nvPr/>
-        </p:nvSpPr>
-        <p:spPr>
-          <a:xfrm>
-            <a:off x="777240" y="4617720"/>
-            <a:ext cx="10972800" cy="640080"/>
+              <a:t>Tested on the held-out 2024-25 season via pre-registered overreaction tests on trailing-team scoring events.</a:t>
+            </a:r>
+            <a:endParaRPr lang="en-US" sz="1300" dirty="0"/>
+          </a:p>
+        </p:txBody>
+      </p:sp>
+      <p:sp>
+        <p:nvSpPr>
+          <p:cNvPr id="12" name="Text 10"/>
+          <p:cNvSpPr/>
+          <p:nvPr/>
+        </p:nvSpPr>
+        <p:spPr>
+          <a:xfrm>
+            <a:off x="685800" y="5760720"/>
+            <a:ext cx="5120640" cy="320040"/>
           </a:xfrm>
           <a:prstGeom prst="rect">
             <a:avLst/>
@@ -6509,44 +6684,96 @@
               <a:buNone/>
             </a:pPr>
             <a:r>
-              <a:rPr lang="en-US" sz="1600" b="1" dirty="0">
-                <a:solidFill>
-                  <a:srgbClr val="EEA02B"/>
+              <a:rPr lang="en-US" sz="1100" i="1" dirty="0">
+                <a:solidFill>
+                  <a:srgbClr val="1C7293"/>
                 </a:solidFill>
                 <a:latin typeface="Calibri" pitchFamily="34" charset="0"/>
                 <a:ea typeface="Calibri" pitchFamily="34" charset="-122"/>
                 <a:cs typeface="Calibri" pitchFamily="34" charset="-120"/>
               </a:rPr>
-              <a:t>H4 (secondary)</a:t>
-            </a:r>
+              <a:t>→ answered on the overreaction-test slide</a:t>
+            </a:r>
+            <a:endParaRPr lang="en-US" sz="1100" dirty="0"/>
+          </a:p>
+        </p:txBody>
+      </p:sp>
+      <p:sp>
+        <p:nvSpPr>
+          <p:cNvPr id="13" name="Shape 11"/>
+          <p:cNvSpPr/>
+          <p:nvPr/>
+        </p:nvSpPr>
+        <p:spPr>
+          <a:xfrm>
+            <a:off x="6263640" y="3840480"/>
+            <a:ext cx="5486400" cy="2377440"/>
+          </a:xfrm>
+          <a:prstGeom prst="roundRect">
+            <a:avLst>
+              <a:gd name="adj" fmla="val 3846"/>
+            </a:avLst>
+          </a:prstGeom>
+          <a:solidFill>
+            <a:srgbClr val="EEF3F8"/>
+          </a:solidFill>
+          <a:ln w="19050">
+            <a:solidFill>
+              <a:srgbClr val="EEA02B"/>
+            </a:solidFill>
+            <a:prstDash val="solid"/>
+          </a:ln>
+        </p:spPr>
+      </p:sp>
+      <p:sp>
+        <p:nvSpPr>
+          <p:cNvPr id="14" name="Text 12"/>
+          <p:cNvSpPr/>
+          <p:nvPr/>
+        </p:nvSpPr>
+        <p:spPr>
+          <a:xfrm>
+            <a:off x="6446520" y="3931920"/>
+            <a:ext cx="5120640" cy="320040"/>
+          </a:xfrm>
+          <a:prstGeom prst="rect">
+            <a:avLst/>
+          </a:prstGeom>
+          <a:noFill/>
+          <a:ln/>
+        </p:spPr>
+        <p:txBody>
+          <a:bodyPr wrap="square" rtlCol="0" anchor="ctr"/>
+          <a:lstStyle/>
+          <a:p>
             <a:pPr indent="0" marL="0">
               <a:buNone/>
             </a:pPr>
             <a:r>
-              <a:rPr lang="en-US" sz="1600" dirty="0">
-                <a:solidFill>
-                  <a:srgbClr val="1A1A1A"/>
+              <a:rPr lang="en-US" sz="1100" b="1" dirty="0">
+                <a:solidFill>
+                  <a:srgbClr val="13315C"/>
                 </a:solidFill>
                 <a:latin typeface="Calibri" pitchFamily="34" charset="0"/>
                 <a:ea typeface="Calibri" pitchFamily="34" charset="-122"/>
                 <a:cs typeface="Calibri" pitchFamily="34" charset="-120"/>
               </a:rPr>
-              <a:t> — trailing team in ≥10 pt deficit hits a made 3-pointer → larger over-shift.</a:t>
-            </a:r>
-            <a:endParaRPr lang="en-US" sz="1600" dirty="0"/>
-          </a:p>
-        </p:txBody>
-      </p:sp>
-      <p:sp>
-        <p:nvSpPr>
-          <p:cNvPr id="10" name="Text 8"/>
-          <p:cNvSpPr/>
-          <p:nvPr/>
-        </p:nvSpPr>
-        <p:spPr>
-          <a:xfrm>
-            <a:off x="502920" y="5669280"/>
-            <a:ext cx="11247120" cy="457200"/>
+              <a:t>SUB-QUESTION 2</a:t>
+            </a:r>
+            <a:endParaRPr lang="en-US" sz="1100" dirty="0"/>
+          </a:p>
+        </p:txBody>
+      </p:sp>
+      <p:sp>
+        <p:nvSpPr>
+          <p:cNvPr id="15" name="Text 13"/>
+          <p:cNvSpPr/>
+          <p:nvPr/>
+        </p:nvSpPr>
+        <p:spPr>
+          <a:xfrm>
+            <a:off x="6446520" y="4206240"/>
+            <a:ext cx="5120640" cy="457200"/>
           </a:xfrm>
           <a:prstGeom prst="rect">
             <a:avLst/>
@@ -6562,15 +6789,54 @@
               <a:buNone/>
             </a:pPr>
             <a:r>
-              <a:rPr lang="en-US" sz="1300" i="1" dirty="0">
-                <a:solidFill>
-                  <a:srgbClr val="8DA9C4"/>
+              <a:rPr lang="en-US" sz="1900" b="1" dirty="0">
+                <a:solidFill>
+                  <a:srgbClr val="0B2545"/>
+                </a:solidFill>
+                <a:latin typeface="Georgia" pitchFamily="34" charset="0"/>
+                <a:ea typeface="Georgia" pitchFamily="34" charset="-122"/>
+                <a:cs typeface="Georgia" pitchFamily="34" charset="-120"/>
+              </a:rPr>
+              <a:t>Can we EXTRACT it (make money)?</a:t>
+            </a:r>
+            <a:endParaRPr lang="en-US" sz="1900" dirty="0"/>
+          </a:p>
+        </p:txBody>
+      </p:sp>
+      <p:sp>
+        <p:nvSpPr>
+          <p:cNvPr id="16" name="Text 14"/>
+          <p:cNvSpPr/>
+          <p:nvPr/>
+        </p:nvSpPr>
+        <p:spPr>
+          <a:xfrm>
+            <a:off x="6446520" y="4709160"/>
+            <a:ext cx="5120640" cy="960120"/>
+          </a:xfrm>
+          <a:prstGeom prst="rect">
+            <a:avLst/>
+          </a:prstGeom>
+          <a:noFill/>
+          <a:ln/>
+        </p:spPr>
+        <p:txBody>
+          <a:bodyPr wrap="square" rtlCol="0" anchor="ctr"/>
+          <a:lstStyle/>
+          <a:p>
+            <a:pPr indent="0" marL="0">
+              <a:buNone/>
+            </a:pPr>
+            <a:r>
+              <a:rPr lang="en-US" sz="1300" dirty="0">
+                <a:solidFill>
+                  <a:srgbClr val="1A1A1A"/>
                 </a:solidFill>
                 <a:latin typeface="Calibri" pitchFamily="34" charset="0"/>
                 <a:ea typeface="Calibri" pitchFamily="34" charset="-122"/>
                 <a:cs typeface="Calibri" pitchFamily="34" charset="-120"/>
               </a:rPr>
-              <a:t>Block-bootstrap by game (n = games, not ticks). Holm-Bonferroni across the pre-registered set.</a:t>
+              <a:t>Tested via live backtest on real markets — does the edge survive the vig at a sample large enough to distinguish skill from luck?</a:t>
             </a:r>
             <a:endParaRPr lang="en-US" sz="1300" dirty="0"/>
           </a:p>
@@ -6578,14 +6844,14 @@
       </p:sp>
       <p:sp>
         <p:nvSpPr>
-          <p:cNvPr id="11" name="Text 9"/>
-          <p:cNvSpPr/>
-          <p:nvPr/>
-        </p:nvSpPr>
-        <p:spPr>
-          <a:xfrm>
-            <a:off x="502920" y="6492240"/>
-            <a:ext cx="7315200" cy="274320"/>
+          <p:cNvPr id="17" name="Text 15"/>
+          <p:cNvSpPr/>
+          <p:nvPr/>
+        </p:nvSpPr>
+        <p:spPr>
+          <a:xfrm>
+            <a:off x="6446520" y="5760720"/>
+            <a:ext cx="5120640" cy="320040"/>
           </a:xfrm>
           <a:prstGeom prst="rect">
             <a:avLst/>
@@ -6601,14 +6867,53 @@
               <a:buNone/>
             </a:pPr>
             <a:r>
-              <a:rPr lang="en-US" sz="1000" dirty="0">
-                <a:solidFill>
-                  <a:srgbClr val="8DA9C4"/>
+              <a:rPr lang="en-US" sz="1100" i="1" dirty="0">
+                <a:solidFill>
+                  <a:srgbClr val="1C7293"/>
                 </a:solidFill>
                 <a:latin typeface="Calibri" pitchFamily="34" charset="0"/>
                 <a:ea typeface="Calibri" pitchFamily="34" charset="-122"/>
                 <a:cs typeface="Calibri" pitchFamily="34" charset="-120"/>
               </a:rPr>
+              <a:t>→ answered on the live-pilot + verdict slides</a:t>
+            </a:r>
+            <a:endParaRPr lang="en-US" sz="1100" dirty="0"/>
+          </a:p>
+        </p:txBody>
+      </p:sp>
+      <p:sp>
+        <p:nvSpPr>
+          <p:cNvPr id="18" name="Text 16"/>
+          <p:cNvSpPr/>
+          <p:nvPr/>
+        </p:nvSpPr>
+        <p:spPr>
+          <a:xfrm>
+            <a:off x="502920" y="6492240"/>
+            <a:ext cx="7315200" cy="274320"/>
+          </a:xfrm>
+          <a:prstGeom prst="rect">
+            <a:avLst/>
+          </a:prstGeom>
+          <a:noFill/>
+          <a:ln/>
+        </p:spPr>
+        <p:txBody>
+          <a:bodyPr wrap="square" rtlCol="0" anchor="ctr"/>
+          <a:lstStyle/>
+          <a:p>
+            <a:pPr indent="0" marL="0">
+              <a:buNone/>
+            </a:pPr>
+            <a:r>
+              <a:rPr lang="en-US" sz="1000" dirty="0">
+                <a:solidFill>
+                  <a:srgbClr val="8DA9C4"/>
+                </a:solidFill>
+                <a:latin typeface="Calibri" pitchFamily="34" charset="0"/>
+                <a:ea typeface="Calibri" pitchFamily="34" charset="-122"/>
+                <a:cs typeface="Calibri" pitchFamily="34" charset="-120"/>
+              </a:rPr>
               <a:t>STATS 211 · NBA Mispricing · Sit &amp; Manathattai</a:t>
             </a:r>
             <a:endParaRPr lang="en-US" sz="1000" dirty="0"/>
@@ -6617,7 +6922,7 @@
       </p:sp>
       <p:sp>
         <p:nvSpPr>
-          <p:cNvPr id="12" name="Text 10"/>
+          <p:cNvPr id="19" name="Text 17"/>
           <p:cNvSpPr/>
           <p:nvPr/>
         </p:nvSpPr>
@@ -12186,7 +12491,7 @@
                           <a:ea typeface="Calibri" pitchFamily="34" charset="-122"/>
                           <a:cs typeface="Calibri" pitchFamily="34" charset="-120"/>
                         </a:rPr>
-                        <a:t>H1 — trail 10–15, made FG</a:t>
+                        <a:t>Comeback FG · trail 10–15</a:t>
                       </a:r>
                       <a:endParaRPr lang="en-US" sz="1200" dirty="0">
                         <a:latin typeface="Calibri" charset="0"/>
@@ -12318,7 +12623,7 @@
                           <a:ea typeface="Calibri" pitchFamily="34" charset="-122"/>
                           <a:cs typeface="Calibri" pitchFamily="34" charset="-120"/>
                         </a:rPr>
-                        <a:t>H4 — trail ≥10, made 3PT</a:t>
+                        <a:t>Salience 3PT · trail ≥10</a:t>
                       </a:r>
                       <a:endParaRPr lang="en-US" sz="1200" dirty="0">
                         <a:latin typeface="Calibri" charset="0"/>

</xml_diff>

<commit_message>
Slides: wire variants table to Method 1/2 with arrow callouts
Slide 4 (6 variants) now shows two left-pointing arrows + labeled badges to
the right of the BUILT rows:
  Row 2 (Calibrated WP model)  ← NAVY arrow + 'Method 1' badge (NAVY/CREAM)
  Row 5 (Overreaction test)    ← ACCENT arrow + 'Method 2' badge (ACCENT/NAVY)

Bottom callout now reads: 'The two we built — Method 1 and Method 2 — are the
only ones that work from play-by-play alone...'

Speaker script: explicitly names 'Method 1' / 'Method 2' when pointing at
the table, so the audience picks up the labels before they appear on slides
6-9.
</commit_message>
<xml_diff>
--- a/slides/final_deck.pptx
+++ b/slides/final_deck.pptx
@@ -8458,17 +8458,17 @@
         </p:nvGraphicFramePr>
         <p:xfrm>
           <a:off x="502920" y="1417320"/>
-          <a:ext cx="11247120" cy="914400"/>
+          <a:ext cx="9464040" cy="914400"/>
         </p:xfrm>
         <a:graphic>
           <a:graphicData uri="http://schemas.openxmlformats.org/drawingml/2006/table">
             <a:tbl>
               <a:tblPr/>
               <a:tblGrid>
-                <a:gridCol w="548640"/>
-                <a:gridCol w="4937760"/>
-                <a:gridCol w="3383280"/>
-                <a:gridCol w="2377440"/>
+                <a:gridCol w="457200"/>
+                <a:gridCol w="4160520"/>
+                <a:gridCol w="2834640"/>
+                <a:gridCol w="2011680"/>
               </a:tblGrid>
               <a:tr h="502920">
                 <a:tc>
@@ -10352,6 +10352,188 @@
         </p:nvSpPr>
         <p:spPr>
           <a:xfrm>
+            <a:off x="10012680" y="2542032"/>
+            <a:ext cx="502920" cy="274320"/>
+          </a:xfrm>
+          <a:prstGeom prst="leftArrow">
+            <a:avLst/>
+          </a:prstGeom>
+          <a:solidFill>
+            <a:srgbClr val="0B2545"/>
+          </a:solidFill>
+          <a:ln w="12700">
+            <a:solidFill>
+              <a:srgbClr val="0B2545"/>
+            </a:solidFill>
+            <a:prstDash val="solid"/>
+          </a:ln>
+        </p:spPr>
+      </p:sp>
+      <p:sp>
+        <p:nvSpPr>
+          <p:cNvPr id="7" name="Shape 4"/>
+          <p:cNvSpPr/>
+          <p:nvPr/>
+        </p:nvSpPr>
+        <p:spPr>
+          <a:xfrm>
+            <a:off x="10607040" y="2496312"/>
+            <a:ext cx="1143000" cy="365760"/>
+          </a:xfrm>
+          <a:prstGeom prst="roundRect">
+            <a:avLst>
+              <a:gd name="adj" fmla="val 12500"/>
+            </a:avLst>
+          </a:prstGeom>
+          <a:solidFill>
+            <a:srgbClr val="0B2545"/>
+          </a:solidFill>
+          <a:ln w="12700">
+            <a:solidFill>
+              <a:srgbClr val="0B2545"/>
+            </a:solidFill>
+            <a:prstDash val="solid"/>
+          </a:ln>
+        </p:spPr>
+      </p:sp>
+      <p:sp>
+        <p:nvSpPr>
+          <p:cNvPr id="8" name="Text 5"/>
+          <p:cNvSpPr/>
+          <p:nvPr/>
+        </p:nvSpPr>
+        <p:spPr>
+          <a:xfrm>
+            <a:off x="10607040" y="2496312"/>
+            <a:ext cx="1143000" cy="365760"/>
+          </a:xfrm>
+          <a:prstGeom prst="rect">
+            <a:avLst/>
+          </a:prstGeom>
+          <a:noFill/>
+          <a:ln/>
+        </p:spPr>
+        <p:txBody>
+          <a:bodyPr wrap="square" rtlCol="0" anchor="ctr"/>
+          <a:lstStyle/>
+          <a:p>
+            <a:pPr algn="ctr" indent="0" marL="0">
+              <a:buNone/>
+            </a:pPr>
+            <a:r>
+              <a:rPr lang="en-US" sz="1300" b="1" dirty="0">
+                <a:solidFill>
+                  <a:srgbClr val="F6F6F2"/>
+                </a:solidFill>
+                <a:latin typeface="Georgia" pitchFamily="34" charset="0"/>
+                <a:ea typeface="Georgia" pitchFamily="34" charset="-122"/>
+                <a:cs typeface="Georgia" pitchFamily="34" charset="-120"/>
+              </a:rPr>
+              <a:t>Method 1</a:t>
+            </a:r>
+            <a:endParaRPr lang="en-US" sz="1300" dirty="0"/>
+          </a:p>
+        </p:txBody>
+      </p:sp>
+      <p:sp>
+        <p:nvSpPr>
+          <p:cNvPr id="9" name="Shape 6"/>
+          <p:cNvSpPr/>
+          <p:nvPr/>
+        </p:nvSpPr>
+        <p:spPr>
+          <a:xfrm>
+            <a:off x="10012680" y="4050792"/>
+            <a:ext cx="502920" cy="274320"/>
+          </a:xfrm>
+          <a:prstGeom prst="leftArrow">
+            <a:avLst/>
+          </a:prstGeom>
+          <a:solidFill>
+            <a:srgbClr val="EEA02B"/>
+          </a:solidFill>
+          <a:ln w="12700">
+            <a:solidFill>
+              <a:srgbClr val="EEA02B"/>
+            </a:solidFill>
+            <a:prstDash val="solid"/>
+          </a:ln>
+        </p:spPr>
+      </p:sp>
+      <p:sp>
+        <p:nvSpPr>
+          <p:cNvPr id="10" name="Shape 7"/>
+          <p:cNvSpPr/>
+          <p:nvPr/>
+        </p:nvSpPr>
+        <p:spPr>
+          <a:xfrm>
+            <a:off x="10607040" y="4005072"/>
+            <a:ext cx="1143000" cy="365760"/>
+          </a:xfrm>
+          <a:prstGeom prst="roundRect">
+            <a:avLst>
+              <a:gd name="adj" fmla="val 12500"/>
+            </a:avLst>
+          </a:prstGeom>
+          <a:solidFill>
+            <a:srgbClr val="EEA02B"/>
+          </a:solidFill>
+          <a:ln w="12700">
+            <a:solidFill>
+              <a:srgbClr val="EEA02B"/>
+            </a:solidFill>
+            <a:prstDash val="solid"/>
+          </a:ln>
+        </p:spPr>
+      </p:sp>
+      <p:sp>
+        <p:nvSpPr>
+          <p:cNvPr id="11" name="Text 8"/>
+          <p:cNvSpPr/>
+          <p:nvPr/>
+        </p:nvSpPr>
+        <p:spPr>
+          <a:xfrm>
+            <a:off x="10607040" y="4005072"/>
+            <a:ext cx="1143000" cy="365760"/>
+          </a:xfrm>
+          <a:prstGeom prst="rect">
+            <a:avLst/>
+          </a:prstGeom>
+          <a:noFill/>
+          <a:ln/>
+        </p:spPr>
+        <p:txBody>
+          <a:bodyPr wrap="square" rtlCol="0" anchor="ctr"/>
+          <a:lstStyle/>
+          <a:p>
+            <a:pPr algn="ctr" indent="0" marL="0">
+              <a:buNone/>
+            </a:pPr>
+            <a:r>
+              <a:rPr lang="en-US" sz="1300" b="1" dirty="0">
+                <a:solidFill>
+                  <a:srgbClr val="0B2545"/>
+                </a:solidFill>
+                <a:latin typeface="Georgia" pitchFamily="34" charset="0"/>
+                <a:ea typeface="Georgia" pitchFamily="34" charset="-122"/>
+                <a:cs typeface="Georgia" pitchFamily="34" charset="-120"/>
+              </a:rPr>
+              <a:t>Method 2</a:t>
+            </a:r>
+            <a:endParaRPr lang="en-US" sz="1300" dirty="0"/>
+          </a:p>
+        </p:txBody>
+      </p:sp>
+      <p:sp>
+        <p:nvSpPr>
+          <p:cNvPr id="12" name="Shape 9"/>
+          <p:cNvSpPr/>
+          <p:nvPr/>
+        </p:nvSpPr>
+        <p:spPr>
+          <a:xfrm>
             <a:off x="502920" y="5349240"/>
             <a:ext cx="11247120" cy="960120"/>
           </a:xfrm>
@@ -10373,7 +10555,7 @@
       </p:sp>
       <p:sp>
         <p:nvSpPr>
-          <p:cNvPr id="7" name="Text 4"/>
+          <p:cNvPr id="13" name="Text 10"/>
           <p:cNvSpPr/>
           <p:nvPr/>
         </p:nvSpPr>
@@ -10404,7 +10586,63 @@
                 <a:ea typeface="Georgia" pitchFamily="34" charset="-122"/>
                 <a:cs typeface="Georgia" pitchFamily="34" charset="-120"/>
               </a:rPr>
-              <a:t>The two we built are the only two that work from play-by-play alone. The other four are gated on multi-venue in-play odds history we don't have.</a:t>
+              <a:t>The two we built — </a:t>
+            </a:r>
+            <a:pPr algn="ctr" indent="0" marL="0">
+              <a:buNone/>
+            </a:pPr>
+            <a:r>
+              <a:rPr lang="en-US" sz="1500" b="1" i="1" dirty="0">
+                <a:solidFill>
+                  <a:srgbClr val="0B2545"/>
+                </a:solidFill>
+                <a:latin typeface="Georgia" pitchFamily="34" charset="0"/>
+                <a:ea typeface="Georgia" pitchFamily="34" charset="-122"/>
+                <a:cs typeface="Georgia" pitchFamily="34" charset="-120"/>
+              </a:rPr>
+              <a:t>Method 1 </a:t>
+            </a:r>
+            <a:pPr algn="ctr" indent="0" marL="0">
+              <a:buNone/>
+            </a:pPr>
+            <a:r>
+              <a:rPr lang="en-US" sz="1500" i="1" dirty="0">
+                <a:solidFill>
+                  <a:srgbClr val="0B2545"/>
+                </a:solidFill>
+                <a:latin typeface="Georgia" pitchFamily="34" charset="0"/>
+                <a:ea typeface="Georgia" pitchFamily="34" charset="-122"/>
+                <a:cs typeface="Georgia" pitchFamily="34" charset="-120"/>
+              </a:rPr>
+              <a:t>and </a:t>
+            </a:r>
+            <a:pPr algn="ctr" indent="0" marL="0">
+              <a:buNone/>
+            </a:pPr>
+            <a:r>
+              <a:rPr lang="en-US" sz="1500" b="1" i="1" dirty="0">
+                <a:solidFill>
+                  <a:srgbClr val="EEA02B"/>
+                </a:solidFill>
+                <a:latin typeface="Georgia" pitchFamily="34" charset="0"/>
+                <a:ea typeface="Georgia" pitchFamily="34" charset="-122"/>
+                <a:cs typeface="Georgia" pitchFamily="34" charset="-120"/>
+              </a:rPr>
+              <a:t>Method 2 </a:t>
+            </a:r>
+            <a:pPr algn="ctr" indent="0" marL="0">
+              <a:buNone/>
+            </a:pPr>
+            <a:r>
+              <a:rPr lang="en-US" sz="1500" i="1" dirty="0">
+                <a:solidFill>
+                  <a:srgbClr val="0B2545"/>
+                </a:solidFill>
+                <a:latin typeface="Georgia" pitchFamily="34" charset="0"/>
+                <a:ea typeface="Georgia" pitchFamily="34" charset="-122"/>
+                <a:cs typeface="Georgia" pitchFamily="34" charset="-120"/>
+              </a:rPr>
+              <a:t>— are the only ones that work from play-by-play alone. The other four are gated on multi-venue in-play odds history we don't have.</a:t>
             </a:r>
             <a:endParaRPr lang="en-US" sz="1500" dirty="0"/>
           </a:p>
@@ -10412,7 +10650,7 @@
       </p:sp>
       <p:sp>
         <p:nvSpPr>
-          <p:cNvPr id="8" name="Text 5"/>
+          <p:cNvPr id="14" name="Text 11"/>
           <p:cNvSpPr/>
           <p:nvPr/>
         </p:nvSpPr>
@@ -10451,7 +10689,7 @@
       </p:sp>
       <p:sp>
         <p:nvSpPr>
-          <p:cNvPr id="9" name="Text 6"/>
+          <p:cNvPr id="15" name="Text 12"/>
           <p:cNvSpPr/>
           <p:nvPr/>
         </p:nvSpPr>

</xml_diff>

<commit_message>
Slides: keep results out of Method/Pipeline/Synthesis slides
Per project rule: numbers only on Findings + Verdict.

Pipeline (slide 5):
  XGB box subtitle 'Brier 0.149 OOS' -> 'calibrated WP model'

Method 1 'how it works' (slide 6) OUTPUT box:
  Removed 'Brier 0.149 · ECE 0.008'
  Removed 'on the 2024-25 held-out season'
  Removed '-> trustworthy'
  Replaced with: 'one calibrated probability per minute of game time'
  And: '-> used by Method 2 + the backtest'

Synthesis (slide 10):
  LEFT panel: 'Brier 0.149 OOS, ECE 0.008' -> 'the model is calibrated'
              'the probabilities can be trusted' -> '(numbers on the Finding 1 slide)'
  RIGHT panel: 'both tests p < 0.0001' -> 'the market overshoots p_hat_t'
               'the bias on the model side is real' -> '(numbers on the Finding 2 slide)'

Speaker script slide 10 updated to match (no numbers, references Findings).
</commit_message>
<xml_diff>
--- a/slides/final_deck.pptx
+++ b/slides/final_deck.pptx
@@ -2832,7 +2832,7 @@
                 <a:ea typeface="Calibri" pitchFamily="34" charset="-122"/>
                 <a:cs typeface="Calibri" pitchFamily="34" charset="-120"/>
               </a:rPr>
-              <a:t>FINDING:  </a:t>
+              <a:t>FINDING 1:  </a:t>
             </a:r>
             <a:pPr indent="0" marL="0">
               <a:buNone/>
@@ -2860,7 +2860,7 @@
                 <a:ea typeface="Calibri" pitchFamily="34" charset="-122"/>
                 <a:cs typeface="Calibri" pitchFamily="34" charset="-120"/>
               </a:rPr>
-              <a:t>Brier 0.149 OOS, ECE 0.008</a:t>
+              <a:t>the model is calibrated</a:t>
             </a:r>
             <a:endParaRPr lang="en-US" sz="1400" dirty="0"/>
           </a:p>
@@ -2899,7 +2899,7 @@
                 <a:ea typeface="Calibri" pitchFamily="34" charset="-122"/>
                 <a:cs typeface="Calibri" pitchFamily="34" charset="-120"/>
               </a:rPr>
-              <a:t>the probabilities can be trusted</a:t>
+              <a:t>(numbers on the Finding 1 slide)</a:t>
             </a:r>
             <a:endParaRPr lang="en-US" sz="1100" dirty="0"/>
           </a:p>
@@ -3277,7 +3277,7 @@
                 <a:ea typeface="Calibri" pitchFamily="34" charset="-122"/>
                 <a:cs typeface="Calibri" pitchFamily="34" charset="-120"/>
               </a:rPr>
-              <a:t>FINDING:  </a:t>
+              <a:t>FINDING 2:  </a:t>
             </a:r>
             <a:pPr indent="0" marL="0">
               <a:buNone/>
@@ -3305,7 +3305,7 @@
                 <a:ea typeface="Calibri" pitchFamily="34" charset="-122"/>
                 <a:cs typeface="Calibri" pitchFamily="34" charset="-120"/>
               </a:rPr>
-              <a:t>both tests p &lt; 0.0001</a:t>
+              <a:t>the market overshoots p̂_t</a:t>
             </a:r>
             <a:endParaRPr lang="en-US" sz="1400" dirty="0"/>
           </a:p>
@@ -3344,7 +3344,7 @@
                 <a:ea typeface="Calibri" pitchFamily="34" charset="-122"/>
                 <a:cs typeface="Calibri" pitchFamily="34" charset="-120"/>
               </a:rPr>
-              <a:t>the bias on the model side is real</a:t>
+              <a:t>(numbers on the Finding 2 slide)</a:t>
             </a:r>
             <a:endParaRPr lang="en-US" sz="1100" dirty="0"/>
           </a:p>
@@ -13851,7 +13851,7 @@
         <p:spPr>
           <a:xfrm>
             <a:off x="9006840" y="3931920"/>
-            <a:ext cx="2788920" cy="320040"/>
+            <a:ext cx="2788920" cy="548640"/>
           </a:xfrm>
           <a:prstGeom prst="rect">
             <a:avLst/>
@@ -13875,54 +13875,32 @@
                 <a:ea typeface="Calibri" pitchFamily="34" charset="-122"/>
                 <a:cs typeface="Calibri" pitchFamily="34" charset="-120"/>
               </a:rPr>
-              <a:t>Brier 0.149  ·  ECE 0.008</a:t>
+              <a:t>one calibrated probability</a:t>
             </a:r>
             <a:endParaRPr lang="en-US" sz="1100" dirty="0"/>
           </a:p>
+          <a:p>
+            <a:pPr algn="ctr" indent="0" marL="0">
+              <a:buNone/>
+            </a:pPr>
+            <a:r>
+              <a:rPr lang="en-US" sz="1100" i="1" dirty="0">
+                <a:solidFill>
+                  <a:srgbClr val="13315C"/>
+                </a:solidFill>
+                <a:latin typeface="Calibri" pitchFamily="34" charset="0"/>
+                <a:ea typeface="Calibri" pitchFamily="34" charset="-122"/>
+                <a:cs typeface="Calibri" pitchFamily="34" charset="-120"/>
+              </a:rPr>
+              <a:t>per minute of game time</a:t>
+            </a:r>
+            <a:endParaRPr lang="en-US" sz="1100" dirty="0"/>
+          </a:p>
         </p:txBody>
       </p:sp>
       <p:sp>
         <p:nvSpPr>
           <p:cNvPr id="29" name="Text 27"/>
-          <p:cNvSpPr/>
-          <p:nvPr/>
-        </p:nvSpPr>
-        <p:spPr>
-          <a:xfrm>
-            <a:off x="9006840" y="4206240"/>
-            <a:ext cx="2788920" cy="320040"/>
-          </a:xfrm>
-          <a:prstGeom prst="rect">
-            <a:avLst/>
-          </a:prstGeom>
-          <a:noFill/>
-          <a:ln/>
-        </p:spPr>
-        <p:txBody>
-          <a:bodyPr wrap="square" rtlCol="0" anchor="ctr"/>
-          <a:lstStyle/>
-          <a:p>
-            <a:pPr algn="ctr" indent="0" marL="0">
-              <a:buNone/>
-            </a:pPr>
-            <a:r>
-              <a:rPr lang="en-US" sz="1000" i="1" dirty="0">
-                <a:solidFill>
-                  <a:srgbClr val="8DA9C4"/>
-                </a:solidFill>
-                <a:latin typeface="Calibri" pitchFamily="34" charset="0"/>
-                <a:ea typeface="Calibri" pitchFamily="34" charset="-122"/>
-                <a:cs typeface="Calibri" pitchFamily="34" charset="-120"/>
-              </a:rPr>
-              <a:t>on the 2024-25 held-out season</a:t>
-            </a:r>
-            <a:endParaRPr lang="en-US" sz="1000" dirty="0"/>
-          </a:p>
-        </p:txBody>
-      </p:sp>
-      <p:sp>
-        <p:nvSpPr>
-          <p:cNvPr id="30" name="Text 28"/>
           <p:cNvSpPr/>
           <p:nvPr/>
         </p:nvSpPr>
@@ -13953,7 +13931,7 @@
                 <a:ea typeface="Calibri" pitchFamily="34" charset="-122"/>
                 <a:cs typeface="Calibri" pitchFamily="34" charset="-120"/>
               </a:rPr>
-              <a:t>→ trustworthy</a:t>
+              <a:t>→ used by Method 2 + the backtest</a:t>
             </a:r>
             <a:endParaRPr lang="en-US" sz="1100" dirty="0"/>
           </a:p>
@@ -13961,7 +13939,7 @@
       </p:sp>
       <p:sp>
         <p:nvSpPr>
-          <p:cNvPr id="31" name="Shape 29"/>
+          <p:cNvPr id="30" name="Shape 28"/>
           <p:cNvSpPr/>
           <p:nvPr/>
         </p:nvSpPr>
@@ -13988,7 +13966,7 @@
       </p:sp>
       <p:sp>
         <p:nvSpPr>
-          <p:cNvPr id="32" name="Text 30"/>
+          <p:cNvPr id="31" name="Text 29"/>
           <p:cNvSpPr/>
           <p:nvPr/>
         </p:nvSpPr>
@@ -14027,7 +14005,7 @@
       </p:sp>
       <p:sp>
         <p:nvSpPr>
-          <p:cNvPr id="33" name="Text 31"/>
+          <p:cNvPr id="32" name="Text 30"/>
           <p:cNvSpPr/>
           <p:nvPr/>
         </p:nvSpPr>
@@ -14178,7 +14156,7 @@
       </p:sp>
       <p:sp>
         <p:nvSpPr>
-          <p:cNvPr id="34" name="Text 32"/>
+          <p:cNvPr id="33" name="Text 31"/>
           <p:cNvSpPr/>
           <p:nvPr/>
         </p:nvSpPr>
@@ -14217,7 +14195,7 @@
       </p:sp>
       <p:sp>
         <p:nvSpPr>
-          <p:cNvPr id="35" name="Text 33"/>
+          <p:cNvPr id="34" name="Text 32"/>
           <p:cNvSpPr/>
           <p:nvPr/>
         </p:nvSpPr>

</xml_diff>